<commit_message>
Fixing something pt 2
</commit_message>
<xml_diff>
--- a/Risultati_0386492.pptx
+++ b/Risultati_0386492.pptx
@@ -5,7 +5,7 @@
     <p:sldMasterId id="2147483648" r:id="rId1"/>
   </p:sldMasterIdLst>
   <p:notesMasterIdLst>
-    <p:notesMasterId r:id="rId62"/>
+    <p:notesMasterId r:id="rId65"/>
   </p:notesMasterIdLst>
   <p:sldIdLst>
     <p:sldId id="256" r:id="rId2"/>
@@ -61,13 +61,16 @@
     <p:sldId id="307" r:id="rId52"/>
     <p:sldId id="311" r:id="rId53"/>
     <p:sldId id="312" r:id="rId54"/>
-    <p:sldId id="315" r:id="rId55"/>
-    <p:sldId id="316" r:id="rId56"/>
-    <p:sldId id="313" r:id="rId57"/>
+    <p:sldId id="313" r:id="rId55"/>
+    <p:sldId id="315" r:id="rId56"/>
+    <p:sldId id="316" r:id="rId57"/>
     <p:sldId id="314" r:id="rId58"/>
     <p:sldId id="317" r:id="rId59"/>
     <p:sldId id="303" r:id="rId60"/>
     <p:sldId id="304" r:id="rId61"/>
+    <p:sldId id="318" r:id="rId62"/>
+    <p:sldId id="319" r:id="rId63"/>
+    <p:sldId id="320" r:id="rId64"/>
   </p:sldIdLst>
   <p:sldSz cx="12192000" cy="6858000"/>
   <p:notesSz cx="6858000" cy="9144000"/>
@@ -11731,8 +11734,8 @@
           </a:p>
         </p:txBody>
       </p:sp>
-      <mc:AlternateContent xmlns:mc="http://schemas.openxmlformats.org/markup-compatibility/2006">
-        <mc:Choice xmlns:a14="http://schemas.microsoft.com/office/drawing/2010/main" Requires="a14">
+      <mc:AlternateContent xmlns:mc="http://schemas.openxmlformats.org/markup-compatibility/2006" xmlns:a14="http://schemas.microsoft.com/office/drawing/2010/main">
+        <mc:Choice Requires="a14">
           <p:sp>
             <p:nvSpPr>
               <p:cNvPr id="8" name="CasellaDiTesto 7">
@@ -11841,6 +11844,7 @@
                       <m:sSupPr>
                         <m:ctrlPr>
                           <a:rPr lang="it-IT" sz="3200" i="1" smtClean="0">
+                            <a:latin typeface="Cambria Math" panose="02040503050406030204" pitchFamily="18" charset="0"/>
                             <a:ea typeface="Cambria Math" panose="02040503050406030204" pitchFamily="18" charset="0"/>
                           </a:rPr>
                         </m:ctrlPr>
@@ -11848,6 +11852,7 @@
                       <m:e>
                         <m:r>
                           <a:rPr lang="it-IT" sz="3200" b="0" i="1" smtClean="0">
+                            <a:latin typeface="Cambria Math" panose="02040503050406030204" pitchFamily="18" charset="0"/>
                             <a:ea typeface="Cambria Math" panose="02040503050406030204" pitchFamily="18" charset="0"/>
                           </a:rPr>
                           <m:t>2</m:t>
@@ -11856,6 +11861,7 @@
                       <m:sup>
                         <m:r>
                           <a:rPr lang="it-IT" sz="3200" b="0" i="1" smtClean="0">
+                            <a:latin typeface="Cambria Math" panose="02040503050406030204" pitchFamily="18" charset="0"/>
                             <a:ea typeface="Cambria Math" panose="02040503050406030204" pitchFamily="18" charset="0"/>
                           </a:rPr>
                           <m:t>𝑖</m:t>
@@ -11871,7 +11877,7 @@
             </p:txBody>
           </p:sp>
         </mc:Choice>
-        <mc:Fallback>
+        <mc:Fallback xmlns="">
           <p:sp>
             <p:nvSpPr>
               <p:cNvPr id="8" name="CasellaDiTesto 7">
@@ -12400,8 +12406,8 @@
           </a:p>
         </p:txBody>
       </p:sp>
-      <mc:AlternateContent xmlns:mc="http://schemas.openxmlformats.org/markup-compatibility/2006">
-        <mc:Choice xmlns:a14="http://schemas.microsoft.com/office/drawing/2010/main" Requires="a14">
+      <mc:AlternateContent xmlns:mc="http://schemas.openxmlformats.org/markup-compatibility/2006" xmlns:a14="http://schemas.microsoft.com/office/drawing/2010/main">
+        <mc:Choice Requires="a14">
           <p:sp>
             <p:nvSpPr>
               <p:cNvPr id="8" name="CasellaDiTesto 7">
@@ -12475,7 +12481,8 @@
                     <m:f>
                       <m:fPr>
                         <m:ctrlPr>
-                          <a:rPr lang="it-IT" sz="3200" smtClean="0">
+                          <a:rPr lang="it-IT" sz="3200" i="1" smtClean="0">
+                            <a:latin typeface="Cambria Math" panose="02040503050406030204" pitchFamily="18" charset="0"/>
                             <a:ea typeface="Cambria Math" panose="02040503050406030204" pitchFamily="18" charset="0"/>
                           </a:rPr>
                         </m:ctrlPr>
@@ -12483,6 +12490,7 @@
                       <m:num>
                         <m:r>
                           <a:rPr lang="it-IT" sz="3200" b="0" i="0" smtClean="0">
+                            <a:latin typeface="Cambria Math" panose="02040503050406030204" pitchFamily="18" charset="0"/>
                             <a:ea typeface="Cambria Math" panose="02040503050406030204" pitchFamily="18" charset="0"/>
                           </a:rPr>
                           <m:t>|</m:t>
@@ -12492,12 +12500,14 @@
                             <m:sty m:val="p"/>
                           </m:rPr>
                           <a:rPr lang="it-IT" sz="3200" b="0" i="0" smtClean="0">
+                            <a:latin typeface="Cambria Math" panose="02040503050406030204" pitchFamily="18" charset="0"/>
                             <a:ea typeface="Cambria Math" panose="02040503050406030204" pitchFamily="18" charset="0"/>
                           </a:rPr>
                           <m:t>E</m:t>
                         </m:r>
                         <m:r>
                           <a:rPr lang="it-IT" sz="3200" b="0" i="0" smtClean="0">
+                            <a:latin typeface="Cambria Math" panose="02040503050406030204" pitchFamily="18" charset="0"/>
                             <a:ea typeface="Cambria Math" panose="02040503050406030204" pitchFamily="18" charset="0"/>
                           </a:rPr>
                           <m:t>|</m:t>
@@ -12507,7 +12517,8 @@
                         <m:d>
                           <m:dPr>
                             <m:ctrlPr>
-                              <a:rPr lang="it-IT" sz="3200" smtClean="0">
+                              <a:rPr lang="it-IT" sz="3200" i="1" smtClean="0">
+                                <a:latin typeface="Cambria Math" panose="02040503050406030204" pitchFamily="18" charset="0"/>
                                 <a:ea typeface="Cambria Math" panose="02040503050406030204" pitchFamily="18" charset="0"/>
                               </a:rPr>
                             </m:ctrlPr>
@@ -12525,7 +12536,8 @@
                                   </m:mc>
                                 </m:mcs>
                                 <m:ctrlPr>
-                                  <a:rPr lang="it-IT" sz="3200" smtClean="0">
+                                  <a:rPr lang="it-IT" sz="3200" i="1" smtClean="0">
+                                    <a:latin typeface="Cambria Math" panose="02040503050406030204" pitchFamily="18" charset="0"/>
                                     <a:ea typeface="Cambria Math" panose="02040503050406030204" pitchFamily="18" charset="0"/>
                                   </a:rPr>
                                 </m:ctrlPr>
@@ -12537,7 +12549,8 @@
                                       <m:begChr m:val="|"/>
                                       <m:endChr m:val="|"/>
                                       <m:ctrlPr>
-                                        <a:rPr lang="it-IT" sz="3200" smtClean="0">
+                                        <a:rPr lang="it-IT" sz="3200" i="1" smtClean="0">
+                                          <a:latin typeface="Cambria Math" panose="02040503050406030204" pitchFamily="18" charset="0"/>
                                           <a:ea typeface="Cambria Math" panose="02040503050406030204" pitchFamily="18" charset="0"/>
                                         </a:rPr>
                                       </m:ctrlPr>
@@ -12548,6 +12561,7 @@
                                           <m:sty m:val="p"/>
                                         </m:rPr>
                                         <a:rPr lang="it-IT" sz="3200" b="0" i="0" smtClean="0">
+                                          <a:latin typeface="Cambria Math" panose="02040503050406030204" pitchFamily="18" charset="0"/>
                                           <a:ea typeface="Cambria Math" panose="02040503050406030204" pitchFamily="18" charset="0"/>
                                         </a:rPr>
                                         <m:t>V</m:t>
@@ -12560,6 +12574,7 @@
                                 <m:e>
                                   <m:r>
                                     <a:rPr lang="it-IT" sz="3200" b="0" i="0" smtClean="0">
+                                      <a:latin typeface="Cambria Math" panose="02040503050406030204" pitchFamily="18" charset="0"/>
                                       <a:ea typeface="Cambria Math" panose="02040503050406030204" pitchFamily="18" charset="0"/>
                                     </a:rPr>
                                     <m:t>2</m:t>
@@ -12584,7 +12599,7 @@
                     <m:f>
                       <m:fPr>
                         <m:ctrlPr>
-                          <a:rPr lang="it-IT" sz="3200">
+                          <a:rPr lang="it-IT" sz="3200" i="1">
                             <a:latin typeface="Cambria Math" panose="02040503050406030204" pitchFamily="18" charset="0"/>
                             <a:ea typeface="Cambria Math" panose="02040503050406030204" pitchFamily="18" charset="0"/>
                           </a:rPr>
@@ -12629,7 +12644,7 @@
                             <m:begChr m:val="|"/>
                             <m:endChr m:val="|"/>
                             <m:ctrlPr>
-                              <a:rPr lang="it-IT" sz="3200" smtClean="0">
+                              <a:rPr lang="it-IT" sz="3200" i="1" smtClean="0">
                                 <a:latin typeface="Cambria Math" panose="02040503050406030204" pitchFamily="18" charset="0"/>
                                 <a:ea typeface="Cambria Math" panose="02040503050406030204" pitchFamily="18" charset="0"/>
                               </a:rPr>
@@ -12660,7 +12675,7 @@
                             <m:begChr m:val="|"/>
                             <m:endChr m:val="|"/>
                             <m:ctrlPr>
-                              <a:rPr lang="it-IT" sz="3200" smtClean="0">
+                              <a:rPr lang="it-IT" sz="3200" i="1" smtClean="0">
                                 <a:latin typeface="Cambria Math" panose="02040503050406030204" pitchFamily="18" charset="0"/>
                                 <a:ea typeface="Cambria Math" panose="02040503050406030204" pitchFamily="18" charset="0"/>
                               </a:rPr>
@@ -12758,7 +12773,7 @@
             </p:txBody>
           </p:sp>
         </mc:Choice>
-        <mc:Fallback>
+        <mc:Fallback xmlns="">
           <p:sp>
             <p:nvSpPr>
               <p:cNvPr id="8" name="CasellaDiTesto 7">
@@ -14432,8 +14447,8 @@
           </a:p>
         </p:txBody>
       </p:sp>
-      <mc:AlternateContent xmlns:mc="http://schemas.openxmlformats.org/markup-compatibility/2006">
-        <mc:Choice xmlns:a14="http://schemas.microsoft.com/office/drawing/2010/main" Requires="a14">
+      <mc:AlternateContent xmlns:mc="http://schemas.openxmlformats.org/markup-compatibility/2006" xmlns:a14="http://schemas.microsoft.com/office/drawing/2010/main">
+        <mc:Choice Requires="a14">
           <p:sp>
             <p:nvSpPr>
               <p:cNvPr id="8" name="CasellaDiTesto 7">
@@ -14519,7 +14534,9 @@
                     <m:f>
                       <m:fPr>
                         <m:ctrlPr>
-                          <a:rPr lang="it-IT" sz="3200" smtClean="0"/>
+                          <a:rPr lang="it-IT" sz="3200" i="1" smtClean="0">
+                            <a:latin typeface="Cambria Math" panose="02040503050406030204" pitchFamily="18" charset="0"/>
+                          </a:rPr>
                         </m:ctrlPr>
                       </m:fPr>
                       <m:num>
@@ -14527,16 +14544,14 @@
                           <a:rPr lang="it-IT" sz="3200" b="0" i="0" smtClean="0">
                             <a:latin typeface="Cambria Math" panose="02040503050406030204" pitchFamily="18" charset="0"/>
                           </a:rPr>
-                          <m:t> </m:t>
-                        </m:r>
-                        <m:r>
-                          <a:rPr lang="it-IT" sz="3200" b="0" i="0" smtClean="0"/>
-                          <m:t>(</m:t>
+                          <m:t> (</m:t>
                         </m:r>
                         <m:sSup>
                           <m:sSupPr>
                             <m:ctrlPr>
-                              <a:rPr lang="it-IT" sz="3200" smtClean="0"/>
+                              <a:rPr lang="it-IT" sz="3200" i="1" smtClean="0">
+                                <a:latin typeface="Cambria Math" panose="02040503050406030204" pitchFamily="18" charset="0"/>
+                              </a:rPr>
                             </m:ctrlPr>
                           </m:sSupPr>
                           <m:e>
@@ -14544,28 +14559,38 @@
                               <m:rPr>
                                 <m:sty m:val="p"/>
                               </m:rPr>
-                              <a:rPr lang="it-IT" sz="3200" b="0" i="0" smtClean="0"/>
+                              <a:rPr lang="it-IT" sz="3200" b="0" i="0" smtClean="0">
+                                <a:latin typeface="Cambria Math" panose="02040503050406030204" pitchFamily="18" charset="0"/>
+                              </a:rPr>
                               <m:t>b</m:t>
                             </m:r>
                             <m:r>
-                              <a:rPr lang="it-IT" sz="3200" b="0" i="0" smtClean="0"/>
+                              <a:rPr lang="it-IT" sz="3200" b="0" i="0" smtClean="0">
+                                <a:latin typeface="Cambria Math" panose="02040503050406030204" pitchFamily="18" charset="0"/>
+                              </a:rPr>
                               <m:t>−</m:t>
                             </m:r>
                             <m:r>
                               <m:rPr>
                                 <m:sty m:val="p"/>
                               </m:rPr>
-                              <a:rPr lang="it-IT" sz="3200" b="0" i="0" smtClean="0"/>
+                              <a:rPr lang="it-IT" sz="3200" b="0" i="0" smtClean="0">
+                                <a:latin typeface="Cambria Math" panose="02040503050406030204" pitchFamily="18" charset="0"/>
+                              </a:rPr>
                               <m:t>a</m:t>
                             </m:r>
                             <m:r>
-                              <a:rPr lang="it-IT" sz="3200" b="0" i="0" smtClean="0"/>
+                              <a:rPr lang="it-IT" sz="3200" b="0" i="0" smtClean="0">
+                                <a:latin typeface="Cambria Math" panose="02040503050406030204" pitchFamily="18" charset="0"/>
+                              </a:rPr>
                               <m:t>)</m:t>
                             </m:r>
                           </m:e>
                           <m:sup>
                             <m:r>
-                              <a:rPr lang="it-IT" sz="3200" b="0" i="0" smtClean="0"/>
+                              <a:rPr lang="it-IT" sz="3200" b="0" i="0" smtClean="0">
+                                <a:latin typeface="Cambria Math" panose="02040503050406030204" pitchFamily="18" charset="0"/>
+                              </a:rPr>
                               <m:t>2</m:t>
                             </m:r>
                           </m:sup>
@@ -14573,7 +14598,9 @@
                       </m:num>
                       <m:den>
                         <m:r>
-                          <a:rPr lang="it-IT" sz="3200" b="0" i="0" smtClean="0"/>
+                          <a:rPr lang="it-IT" sz="3200" b="0" i="0" smtClean="0">
+                            <a:latin typeface="Cambria Math" panose="02040503050406030204" pitchFamily="18" charset="0"/>
+                          </a:rPr>
                           <m:t>12</m:t>
                         </m:r>
                       </m:den>
@@ -14638,7 +14665,7 @@
             </p:txBody>
           </p:sp>
         </mc:Choice>
-        <mc:Fallback>
+        <mc:Fallback xmlns="">
           <p:sp>
             <p:nvSpPr>
               <p:cNvPr id="8" name="CasellaDiTesto 7">
@@ -16153,15 +16180,7 @@
             </a:pPr>
             <a:r>
               <a:rPr lang="it-IT" sz="3200" dirty="0"/>
-              <a:t>Sebbene matematicamente andrebbe inserito il &lt; 2, si è osservato che la tolleranza di </a:t>
-            </a:r>
-            <a:r>
-              <a:rPr lang="it-IT" sz="3200" dirty="0" err="1"/>
-              <a:t>Gurobi</a:t>
-            </a:r>
-            <a:r>
-              <a:rPr lang="it-IT" sz="3200" dirty="0"/>
-              <a:t> è di 6 cifre decimali, per evitare loop dovuti a quantità trascurabili si è deciso di considerarne solo 3.</a:t>
+              <a:t>Sebbene matematicamente andrebbe inserito il &lt; 2, si è osservato che la tolleranza del solver è di 6 cifre decimali, per evitare loop dovuti a quantità trascurabili si è deciso di considerarne solo 3.</a:t>
             </a:r>
           </a:p>
         </p:txBody>
@@ -16872,7 +16891,7 @@
                   <a:schemeClr val="bg1"/>
                 </a:solidFill>
               </a:rPr>
-              <a:t>41</a:t>
+              <a:t>45</a:t>
             </a:r>
           </a:p>
         </p:txBody>
@@ -17152,7 +17171,7 @@
                   <a:schemeClr val="bg1"/>
                 </a:solidFill>
               </a:rPr>
-              <a:t>41</a:t>
+              <a:t>46</a:t>
             </a:r>
           </a:p>
         </p:txBody>
@@ -17462,7 +17481,7 @@
                   <a:schemeClr val="bg1"/>
                 </a:solidFill>
               </a:rPr>
-              <a:t>41</a:t>
+              <a:t>47</a:t>
             </a:r>
           </a:p>
         </p:txBody>
@@ -18164,13 +18183,18 @@
           <a:p>
             <a:pPr algn="r"/>
             <a:r>
-              <a:rPr lang="it-IT" sz="2000" b="1" dirty="0">
+              <a:rPr lang="it-IT" sz="2000" b="1">
                 <a:solidFill>
                   <a:schemeClr val="bg1"/>
                 </a:solidFill>
               </a:rPr>
-              <a:t>44</a:t>
-            </a:r>
+              <a:t>48</a:t>
+            </a:r>
+            <a:endParaRPr lang="it-IT" sz="2000" b="1" dirty="0">
+              <a:solidFill>
+                <a:schemeClr val="bg1"/>
+              </a:solidFill>
+            </a:endParaRPr>
           </a:p>
         </p:txBody>
       </p:sp>
@@ -18445,13 +18469,18 @@
           <a:p>
             <a:pPr algn="r"/>
             <a:r>
-              <a:rPr lang="it-IT" sz="2000" b="1" dirty="0">
+              <a:rPr lang="it-IT" sz="2000" b="1">
                 <a:solidFill>
                   <a:schemeClr val="bg1"/>
                 </a:solidFill>
               </a:rPr>
-              <a:t>44</a:t>
-            </a:r>
+              <a:t>49</a:t>
+            </a:r>
+            <a:endParaRPr lang="it-IT" sz="2000" b="1" dirty="0">
+              <a:solidFill>
+                <a:schemeClr val="bg1"/>
+              </a:solidFill>
+            </a:endParaRPr>
           </a:p>
         </p:txBody>
       </p:sp>
@@ -18628,8 +18657,8 @@
           </a:p>
         </p:txBody>
       </p:sp>
-      <mc:AlternateContent xmlns:mc="http://schemas.openxmlformats.org/markup-compatibility/2006">
-        <mc:Choice xmlns:a14="http://schemas.microsoft.com/office/drawing/2010/main" Requires="a14">
+      <mc:AlternateContent xmlns:mc="http://schemas.openxmlformats.org/markup-compatibility/2006" xmlns:a14="http://schemas.microsoft.com/office/drawing/2010/main">
+        <mc:Choice Requires="a14">
           <p:sp>
             <p:nvSpPr>
               <p:cNvPr id="8" name="CasellaDiTesto 7">
@@ -18745,14 +18774,7 @@
                             <a:latin typeface="Cambria Math" panose="02040503050406030204" pitchFamily="18" charset="0"/>
                             <a:ea typeface="Cambria Math" panose="02040503050406030204" pitchFamily="18" charset="0"/>
                           </a:rPr>
-                          <m:t>2</m:t>
-                        </m:r>
-                        <m:r>
-                          <a:rPr lang="it-IT" sz="2800">
-                            <a:latin typeface="Cambria Math" panose="02040503050406030204" pitchFamily="18" charset="0"/>
-                            <a:ea typeface="Cambria Math" panose="02040503050406030204" pitchFamily="18" charset="0"/>
-                          </a:rPr>
-                          <m:t>|</m:t>
+                          <m:t>2|</m:t>
                         </m:r>
                         <m:r>
                           <m:rPr>
@@ -18961,7 +18983,7 @@
             </p:txBody>
           </p:sp>
         </mc:Choice>
-        <mc:Fallback>
+        <mc:Fallback xmlns="">
           <p:sp>
             <p:nvSpPr>
               <p:cNvPr id="8" name="CasellaDiTesto 7">
@@ -19041,7 +19063,7 @@
                   <a:schemeClr val="bg1"/>
                 </a:solidFill>
               </a:rPr>
-              <a:t>41</a:t>
+              <a:t>50</a:t>
             </a:r>
           </a:p>
         </p:txBody>
@@ -19322,7 +19344,7 @@
                   <a:schemeClr val="bg1"/>
                 </a:solidFill>
               </a:rPr>
-              <a:t>41</a:t>
+              <a:t>51</a:t>
             </a:r>
           </a:p>
         </p:txBody>
@@ -19391,7 +19413,7 @@
         <p:cNvPr id="1" name="">
           <a:extLst>
             <a:ext uri="{FF2B5EF4-FFF2-40B4-BE49-F238E27FC236}">
-              <a16:creationId xmlns:a16="http://schemas.microsoft.com/office/drawing/2014/main" id="{B3A19B3B-FB8E-C5A6-9BDE-D35B5983841C}"/>
+              <a16:creationId xmlns:a16="http://schemas.microsoft.com/office/drawing/2014/main" id="{BC703C0D-6076-EDDA-DA62-3FFD560D3070}"/>
             </a:ext>
           </a:extLst>
         </p:cNvPr>
@@ -19411,7 +19433,7 @@
           <p:cNvPr id="5" name="Rettangolo 4">
             <a:extLst>
               <a:ext uri="{FF2B5EF4-FFF2-40B4-BE49-F238E27FC236}">
-                <a16:creationId xmlns:a16="http://schemas.microsoft.com/office/drawing/2014/main" id="{DCB98510-44D4-2C4B-8DD1-C758BCCE5735}"/>
+                <a16:creationId xmlns:a16="http://schemas.microsoft.com/office/drawing/2014/main" id="{20DA4FF2-7B5D-EDBE-99E5-1CC39E1E32F6}"/>
               </a:ext>
             </a:extLst>
           </p:cNvPr>
@@ -19465,7 +19487,7 @@
           <p:cNvPr id="6" name="CasellaDiTesto 5">
             <a:extLst>
               <a:ext uri="{FF2B5EF4-FFF2-40B4-BE49-F238E27FC236}">
-                <a16:creationId xmlns:a16="http://schemas.microsoft.com/office/drawing/2014/main" id="{A94CDE8D-B5A2-F3F2-7BD8-9B307A68CA19}"/>
+                <a16:creationId xmlns:a16="http://schemas.microsoft.com/office/drawing/2014/main" id="{2A63AD9D-B169-C12A-2A0C-144AF23F63FC}"/>
               </a:ext>
             </a:extLst>
           </p:cNvPr>
@@ -19500,8 +19522,311 @@
           </a:p>
         </p:txBody>
       </p:sp>
-      <mc:AlternateContent xmlns:mc="http://schemas.openxmlformats.org/markup-compatibility/2006">
-        <mc:Choice xmlns:a14="http://schemas.microsoft.com/office/drawing/2010/main" Requires="a14">
+      <p:sp>
+        <p:nvSpPr>
+          <p:cNvPr id="8" name="CasellaDiTesto 7">
+            <a:extLst>
+              <a:ext uri="{FF2B5EF4-FFF2-40B4-BE49-F238E27FC236}">
+                <a16:creationId xmlns:a16="http://schemas.microsoft.com/office/drawing/2014/main" id="{D028465C-1A6E-7D80-5C6C-3E04F17A1A6B}"/>
+              </a:ext>
+            </a:extLst>
+          </p:cNvPr>
+          <p:cNvSpPr txBox="1"/>
+          <p:nvPr/>
+        </p:nvSpPr>
+        <p:spPr>
+          <a:xfrm>
+            <a:off x="533399" y="728069"/>
+            <a:ext cx="11116884" cy="5032147"/>
+          </a:xfrm>
+          <a:prstGeom prst="rect">
+            <a:avLst/>
+          </a:prstGeom>
+          <a:noFill/>
+        </p:spPr>
+        <p:txBody>
+          <a:bodyPr wrap="square" rtlCol="0">
+            <a:spAutoFit/>
+          </a:bodyPr>
+          <a:lstStyle/>
+          <a:p>
+            <a:pPr algn="just">
+              <a:spcAft>
+                <a:spcPts val="600"/>
+              </a:spcAft>
+            </a:pPr>
+            <a:r>
+              <a:rPr lang="it-IT" sz="4000" b="1" dirty="0">
+                <a:solidFill>
+                  <a:srgbClr val="990000"/>
+                </a:solidFill>
+              </a:rPr>
+              <a:t>GENERAZIONE DELLE ISTANZE</a:t>
+            </a:r>
+          </a:p>
+          <a:p>
+            <a:pPr algn="just">
+              <a:spcAft>
+                <a:spcPts val="600"/>
+              </a:spcAft>
+            </a:pPr>
+            <a:r>
+              <a:rPr lang="it-IT" sz="3200" b="1" dirty="0"/>
+              <a:t>Vertex cover non pesato – Istruzioni che vale la pena commentare:</a:t>
+            </a:r>
+          </a:p>
+          <a:p>
+            <a:pPr algn="just">
+              <a:spcAft>
+                <a:spcPts val="600"/>
+              </a:spcAft>
+            </a:pPr>
+            <a:endParaRPr lang="it-IT" sz="3200" b="1" dirty="0"/>
+          </a:p>
+          <a:p>
+            <a:pPr algn="just">
+              <a:spcAft>
+                <a:spcPts val="600"/>
+              </a:spcAft>
+            </a:pPr>
+            <a:endParaRPr lang="it-IT" sz="3200" b="1" dirty="0"/>
+          </a:p>
+          <a:p>
+            <a:pPr algn="just">
+              <a:spcAft>
+                <a:spcPts val="600"/>
+              </a:spcAft>
+            </a:pPr>
+            <a:endParaRPr lang="it-IT" sz="3200" b="1" dirty="0"/>
+          </a:p>
+          <a:p>
+            <a:pPr algn="just">
+              <a:spcAft>
+                <a:spcPts val="600"/>
+              </a:spcAft>
+            </a:pPr>
+            <a:r>
+              <a:rPr lang="it-IT" sz="3200" dirty="0"/>
+              <a:t>Si utilizza una normale perché è una variabile aleatoria la cui varianza non si ottiene in modo matematico a partire dalla media (si può modificare a piacimento mantenendo la media fissa).</a:t>
+            </a:r>
+          </a:p>
+        </p:txBody>
+      </p:sp>
+      <p:sp>
+        <p:nvSpPr>
+          <p:cNvPr id="2" name="CasellaDiTesto 1">
+            <a:extLst>
+              <a:ext uri="{FF2B5EF4-FFF2-40B4-BE49-F238E27FC236}">
+                <a16:creationId xmlns:a16="http://schemas.microsoft.com/office/drawing/2014/main" id="{BB63DFD3-C9E3-9EFF-F47F-CFF1391A6858}"/>
+              </a:ext>
+            </a:extLst>
+          </p:cNvPr>
+          <p:cNvSpPr txBox="1"/>
+          <p:nvPr/>
+        </p:nvSpPr>
+        <p:spPr>
+          <a:xfrm>
+            <a:off x="11434917" y="6222490"/>
+            <a:ext cx="491612" cy="400110"/>
+          </a:xfrm>
+          <a:prstGeom prst="rect">
+            <a:avLst/>
+          </a:prstGeom>
+          <a:noFill/>
+        </p:spPr>
+        <p:txBody>
+          <a:bodyPr wrap="square" rtlCol="0">
+            <a:spAutoFit/>
+          </a:bodyPr>
+          <a:lstStyle/>
+          <a:p>
+            <a:pPr algn="r"/>
+            <a:r>
+              <a:rPr lang="it-IT" sz="2000" b="1" dirty="0">
+                <a:solidFill>
+                  <a:schemeClr val="bg1"/>
+                </a:solidFill>
+              </a:rPr>
+              <a:t>52</a:t>
+            </a:r>
+          </a:p>
+        </p:txBody>
+      </p:sp>
+      <p:pic>
+        <p:nvPicPr>
+          <p:cNvPr id="7" name="Immagine 6">
+            <a:extLst>
+              <a:ext uri="{FF2B5EF4-FFF2-40B4-BE49-F238E27FC236}">
+                <a16:creationId xmlns:a16="http://schemas.microsoft.com/office/drawing/2014/main" id="{C1D6FA59-3C57-891A-8CE1-008016D91F4A}"/>
+              </a:ext>
+            </a:extLst>
+          </p:cNvPr>
+          <p:cNvPicPr>
+            <a:picLocks noChangeAspect="1"/>
+          </p:cNvPicPr>
+          <p:nvPr/>
+        </p:nvPicPr>
+        <p:blipFill>
+          <a:blip r:embed="rId2"/>
+          <a:srcRect t="47356" b="5339"/>
+          <a:stretch>
+            <a:fillRect/>
+          </a:stretch>
+        </p:blipFill>
+        <p:spPr>
+          <a:xfrm>
+            <a:off x="533399" y="2445773"/>
+            <a:ext cx="8708924" cy="1785979"/>
+          </a:xfrm>
+          <a:prstGeom prst="rect">
+            <a:avLst/>
+          </a:prstGeom>
+        </p:spPr>
+      </p:pic>
+    </p:spTree>
+    <p:extLst>
+      <p:ext uri="{BB962C8B-B14F-4D97-AF65-F5344CB8AC3E}">
+        <p14:creationId xmlns:p14="http://schemas.microsoft.com/office/powerpoint/2010/main" val="2990189964"/>
+      </p:ext>
+    </p:extLst>
+  </p:cSld>
+  <p:clrMapOvr>
+    <a:masterClrMapping/>
+  </p:clrMapOvr>
+  <mc:AlternateContent xmlns:mc="http://schemas.openxmlformats.org/markup-compatibility/2006" xmlns:p159="http://schemas.microsoft.com/office/powerpoint/2015/09/main">
+    <mc:Choice Requires="p159">
+      <p:transition xmlns:p14="http://schemas.microsoft.com/office/powerpoint/2010/main" spd="slow" p14:dur="2000">
+        <p159:morph option="byObject"/>
+      </p:transition>
+    </mc:Choice>
+    <mc:Fallback xmlns="">
+      <p:transition spd="slow">
+        <p:fade/>
+      </p:transition>
+    </mc:Fallback>
+  </mc:AlternateContent>
+</p:sld>
+</file>
+
+<file path=ppt/slides/slide55.xml><?xml version="1.0" encoding="utf-8"?>
+<p:sld xmlns:a="http://schemas.openxmlformats.org/drawingml/2006/main" xmlns:r="http://schemas.openxmlformats.org/officeDocument/2006/relationships" xmlns:p="http://schemas.openxmlformats.org/presentationml/2006/main">
+  <p:cSld>
+    <p:spTree>
+      <p:nvGrpSpPr>
+        <p:cNvPr id="1" name="">
+          <a:extLst>
+            <a:ext uri="{FF2B5EF4-FFF2-40B4-BE49-F238E27FC236}">
+              <a16:creationId xmlns:a16="http://schemas.microsoft.com/office/drawing/2014/main" id="{B3A19B3B-FB8E-C5A6-9BDE-D35B5983841C}"/>
+            </a:ext>
+          </a:extLst>
+        </p:cNvPr>
+        <p:cNvGrpSpPr/>
+        <p:nvPr/>
+      </p:nvGrpSpPr>
+      <p:grpSpPr>
+        <a:xfrm>
+          <a:off x="0" y="0"/>
+          <a:ext cx="0" cy="0"/>
+          <a:chOff x="0" y="0"/>
+          <a:chExt cx="0" cy="0"/>
+        </a:xfrm>
+      </p:grpSpPr>
+      <p:sp>
+        <p:nvSpPr>
+          <p:cNvPr id="5" name="Rettangolo 4">
+            <a:extLst>
+              <a:ext uri="{FF2B5EF4-FFF2-40B4-BE49-F238E27FC236}">
+                <a16:creationId xmlns:a16="http://schemas.microsoft.com/office/drawing/2014/main" id="{DCB98510-44D4-2C4B-8DD1-C758BCCE5735}"/>
+              </a:ext>
+            </a:extLst>
+          </p:cNvPr>
+          <p:cNvSpPr/>
+          <p:nvPr/>
+        </p:nvSpPr>
+        <p:spPr>
+          <a:xfrm rot="16200000">
+            <a:off x="5612871" y="326546"/>
+            <a:ext cx="966258" cy="12192000"/>
+          </a:xfrm>
+          <a:prstGeom prst="rect">
+            <a:avLst/>
+          </a:prstGeom>
+          <a:solidFill>
+            <a:srgbClr val="990000"/>
+          </a:solidFill>
+          <a:ln>
+            <a:solidFill>
+              <a:srgbClr val="990000"/>
+            </a:solidFill>
+          </a:ln>
+        </p:spPr>
+        <p:style>
+          <a:lnRef idx="2">
+            <a:schemeClr val="accent1">
+              <a:shade val="15000"/>
+            </a:schemeClr>
+          </a:lnRef>
+          <a:fillRef idx="1">
+            <a:schemeClr val="accent1"/>
+          </a:fillRef>
+          <a:effectRef idx="0">
+            <a:schemeClr val="accent1"/>
+          </a:effectRef>
+          <a:fontRef idx="minor">
+            <a:schemeClr val="lt1"/>
+          </a:fontRef>
+        </p:style>
+        <p:txBody>
+          <a:bodyPr rtlCol="0" anchor="ctr"/>
+          <a:lstStyle/>
+          <a:p>
+            <a:pPr algn="ctr"/>
+            <a:endParaRPr lang="it-IT" dirty="0"/>
+          </a:p>
+        </p:txBody>
+      </p:sp>
+      <p:sp>
+        <p:nvSpPr>
+          <p:cNvPr id="6" name="CasellaDiTesto 5">
+            <a:extLst>
+              <a:ext uri="{FF2B5EF4-FFF2-40B4-BE49-F238E27FC236}">
+                <a16:creationId xmlns:a16="http://schemas.microsoft.com/office/drawing/2014/main" id="{A94CDE8D-B5A2-F3F2-7BD8-9B307A68CA19}"/>
+              </a:ext>
+            </a:extLst>
+          </p:cNvPr>
+          <p:cNvSpPr txBox="1"/>
+          <p:nvPr/>
+        </p:nvSpPr>
+        <p:spPr>
+          <a:xfrm>
+            <a:off x="5086139" y="6222490"/>
+            <a:ext cx="2019720" cy="400110"/>
+          </a:xfrm>
+          <a:prstGeom prst="rect">
+            <a:avLst/>
+          </a:prstGeom>
+          <a:noFill/>
+        </p:spPr>
+        <p:txBody>
+          <a:bodyPr wrap="square" rtlCol="0">
+            <a:spAutoFit/>
+          </a:bodyPr>
+          <a:lstStyle/>
+          <a:p>
+            <a:pPr algn="r"/>
+            <a:r>
+              <a:rPr lang="it-IT" sz="2000" b="1" dirty="0">
+                <a:solidFill>
+                  <a:schemeClr val="bg1"/>
+                </a:solidFill>
+              </a:rPr>
+              <a:t>Gianpaolo Pestilli</a:t>
+            </a:r>
+          </a:p>
+        </p:txBody>
+      </p:sp>
+      <mc:AlternateContent xmlns:mc="http://schemas.openxmlformats.org/markup-compatibility/2006" xmlns:a14="http://schemas.microsoft.com/office/drawing/2010/main">
+        <mc:Choice Requires="a14">
           <p:sp>
             <p:nvSpPr>
               <p:cNvPr id="8" name="CasellaDiTesto 7">
@@ -19620,7 +19945,9 @@
                     <m:f>
                       <m:fPr>
                         <m:ctrlPr>
-                          <a:rPr lang="it-IT" sz="2800" smtClean="0"/>
+                          <a:rPr lang="it-IT" sz="2800" i="1" smtClean="0">
+                            <a:latin typeface="Cambria Math" panose="02040503050406030204" pitchFamily="18" charset="0"/>
+                          </a:rPr>
                         </m:ctrlPr>
                       </m:fPr>
                       <m:num>
@@ -19628,18 +19955,24 @@
                           <m:rPr>
                             <m:sty m:val="p"/>
                           </m:rPr>
-                          <a:rPr lang="it-IT" sz="2800" b="0" i="0" smtClean="0"/>
+                          <a:rPr lang="it-IT" sz="2800" b="0" i="0" smtClean="0">
+                            <a:latin typeface="Cambria Math" panose="02040503050406030204" pitchFamily="18" charset="0"/>
+                          </a:rPr>
                           <m:t>deg</m:t>
                         </m:r>
                         <m:r>
-                          <a:rPr lang="it-IT" sz="2800" b="0" i="0" smtClean="0"/>
+                          <a:rPr lang="it-IT" sz="2800" b="0" i="0" smtClean="0">
+                            <a:latin typeface="Cambria Math" panose="02040503050406030204" pitchFamily="18" charset="0"/>
+                          </a:rPr>
                           <m:t>_</m:t>
                         </m:r>
                         <m:r>
                           <m:rPr>
                             <m:sty m:val="p"/>
                           </m:rPr>
-                          <a:rPr lang="it-IT" sz="2800" b="0" i="0" smtClean="0"/>
+                          <a:rPr lang="it-IT" sz="2800" b="0" i="0" smtClean="0">
+                            <a:latin typeface="Cambria Math" panose="02040503050406030204" pitchFamily="18" charset="0"/>
+                          </a:rPr>
                           <m:t>max</m:t>
                         </m:r>
                       </m:num>
@@ -19648,18 +19981,24 @@
                           <m:rPr>
                             <m:sty m:val="p"/>
                           </m:rPr>
-                          <a:rPr lang="it-IT" sz="2800" b="0" i="0" smtClean="0"/>
+                          <a:rPr lang="it-IT" sz="2800" b="0" i="0" smtClean="0">
+                            <a:latin typeface="Cambria Math" panose="02040503050406030204" pitchFamily="18" charset="0"/>
+                          </a:rPr>
                           <m:t>deg</m:t>
                         </m:r>
                         <m:r>
-                          <a:rPr lang="it-IT" sz="2800" b="0" i="0" smtClean="0"/>
+                          <a:rPr lang="it-IT" sz="2800" b="0" i="0" smtClean="0">
+                            <a:latin typeface="Cambria Math" panose="02040503050406030204" pitchFamily="18" charset="0"/>
+                          </a:rPr>
                           <m:t>⁡_</m:t>
                         </m:r>
                         <m:r>
                           <m:rPr>
                             <m:sty m:val="p"/>
                           </m:rPr>
-                          <a:rPr lang="it-IT" sz="2800" b="0" i="0" smtClean="0"/>
+                          <a:rPr lang="it-IT" sz="2800" b="0" i="0" smtClean="0">
+                            <a:latin typeface="Cambria Math" panose="02040503050406030204" pitchFamily="18" charset="0"/>
+                          </a:rPr>
                           <m:t>medio</m:t>
                         </m:r>
                       </m:den>
@@ -19707,7 +20046,9 @@
                 <a14:m>
                   <m:oMath xmlns:m="http://schemas.openxmlformats.org/officeDocument/2006/math">
                     <m:r>
-                      <a:rPr lang="it-IT" sz="2800" i="1" dirty="0" smtClean="0"/>
+                      <a:rPr lang="it-IT" sz="2800" i="1" dirty="0" smtClean="0">
+                        <a:latin typeface="Cambria Math" panose="02040503050406030204" pitchFamily="18" charset="0"/>
+                      </a:rPr>
                       <m:t>𝜇</m:t>
                     </m:r>
                   </m:oMath>
@@ -19719,7 +20060,9 @@
                 <a14:m>
                   <m:oMath xmlns:m="http://schemas.openxmlformats.org/officeDocument/2006/math">
                     <m:r>
-                      <a:rPr lang="it-IT" sz="2800" i="1" dirty="0"/>
+                      <a:rPr lang="it-IT" sz="2800" i="1" dirty="0">
+                        <a:latin typeface="Cambria Math" panose="02040503050406030204" pitchFamily="18" charset="0"/>
+                      </a:rPr>
                       <m:t>𝜎</m:t>
                     </m:r>
                   </m:oMath>
@@ -19741,7 +20084,9 @@
                 <a14:m>
                   <m:oMath xmlns:m="http://schemas.openxmlformats.org/officeDocument/2006/math">
                     <m:r>
-                      <a:rPr lang="it-IT" sz="2800" dirty="0"/>
+                      <a:rPr lang="it-IT" sz="2800" dirty="0">
+                        <a:latin typeface="Cambria Math" panose="02040503050406030204" pitchFamily="18" charset="0"/>
+                      </a:rPr>
                       <m:t>≈</m:t>
                     </m:r>
                   </m:oMath>
@@ -19755,12 +20100,16 @@
                     <m:f>
                       <m:fPr>
                         <m:ctrlPr>
-                          <a:rPr lang="it-IT" sz="2800" i="1"/>
+                          <a:rPr lang="it-IT" sz="2800" i="1">
+                            <a:latin typeface="Cambria Math" panose="02040503050406030204" pitchFamily="18" charset="0"/>
+                          </a:rPr>
                         </m:ctrlPr>
                       </m:fPr>
                       <m:num>
                         <m:r>
-                          <a:rPr lang="it-IT" sz="2800" i="1" dirty="0"/>
+                          <a:rPr lang="it-IT" sz="2800" i="1" dirty="0">
+                            <a:latin typeface="Cambria Math" panose="02040503050406030204" pitchFamily="18" charset="0"/>
+                          </a:rPr>
                           <m:t>𝜇</m:t>
                         </m:r>
                         <m:r>
@@ -19771,7 +20120,9 @@
                           <m:t> + 3 </m:t>
                         </m:r>
                         <m:r>
-                          <a:rPr lang="it-IT" sz="2800" i="1" dirty="0"/>
+                          <a:rPr lang="it-IT" sz="2800" i="1" dirty="0">
+                            <a:latin typeface="Cambria Math" panose="02040503050406030204" pitchFamily="18" charset="0"/>
+                          </a:rPr>
                           <m:t>𝜎</m:t>
                         </m:r>
                         <m:r>
@@ -19784,7 +20135,9 @@
                       </m:num>
                       <m:den>
                         <m:r>
-                          <a:rPr lang="it-IT" sz="2800" i="1" dirty="0"/>
+                          <a:rPr lang="it-IT" sz="2800" i="1" dirty="0">
+                            <a:latin typeface="Cambria Math" panose="02040503050406030204" pitchFamily="18" charset="0"/>
+                          </a:rPr>
                           <m:t>𝜇</m:t>
                         </m:r>
                       </m:den>
@@ -19822,7 +20175,9 @@
                 <a14:m>
                   <m:oMath xmlns:m="http://schemas.openxmlformats.org/officeDocument/2006/math">
                     <m:r>
-                      <a:rPr lang="it-IT" sz="2800" dirty="0"/>
+                      <a:rPr lang="it-IT" sz="2800" dirty="0">
+                        <a:latin typeface="Cambria Math" panose="02040503050406030204" pitchFamily="18" charset="0"/>
+                      </a:rPr>
                       <m:t>≈</m:t>
                     </m:r>
                   </m:oMath>
@@ -19836,18 +20191,24 @@
                     <m:f>
                       <m:fPr>
                         <m:ctrlPr>
-                          <a:rPr lang="it-IT" sz="2800" i="1"/>
+                          <a:rPr lang="it-IT" sz="2800" i="1">
+                            <a:latin typeface="Cambria Math" panose="02040503050406030204" pitchFamily="18" charset="0"/>
+                          </a:rPr>
                         </m:ctrlPr>
                       </m:fPr>
                       <m:num>
                         <m:r>
-                          <a:rPr lang="it-IT" sz="2800" b="0" i="1" dirty="0" smtClean="0"/>
+                          <a:rPr lang="it-IT" sz="2800" b="0" i="1" dirty="0" smtClean="0">
+                            <a:latin typeface="Cambria Math" panose="02040503050406030204" pitchFamily="18" charset="0"/>
+                          </a:rPr>
                           <m:t>1.2+1.6</m:t>
                         </m:r>
                       </m:num>
                       <m:den>
                         <m:r>
-                          <a:rPr lang="it-IT" sz="2800" b="0" i="1" dirty="0" smtClean="0"/>
+                          <a:rPr lang="it-IT" sz="2800" b="0" i="1" dirty="0" smtClean="0">
+                            <a:latin typeface="Cambria Math" panose="02040503050406030204" pitchFamily="18" charset="0"/>
+                          </a:rPr>
                           <m:t>2</m:t>
                         </m:r>
                       </m:den>
@@ -19872,7 +20233,7 @@
             </p:txBody>
           </p:sp>
         </mc:Choice>
-        <mc:Fallback>
+        <mc:Fallback xmlns="">
           <p:sp>
             <p:nvSpPr>
               <p:cNvPr id="8" name="CasellaDiTesto 7">
@@ -19952,7 +20313,7 @@
                   <a:schemeClr val="bg1"/>
                 </a:solidFill>
               </a:rPr>
-              <a:t>41</a:t>
+              <a:t>53</a:t>
             </a:r>
           </a:p>
         </p:txBody>
@@ -19982,7 +20343,7 @@
 </p:sld>
 </file>
 
-<file path=ppt/slides/slide55.xml><?xml version="1.0" encoding="utf-8"?>
+<file path=ppt/slides/slide56.xml><?xml version="1.0" encoding="utf-8"?>
 <p:sld xmlns:a="http://schemas.openxmlformats.org/drawingml/2006/main" xmlns:r="http://schemas.openxmlformats.org/officeDocument/2006/relationships" xmlns:p="http://schemas.openxmlformats.org/presentationml/2006/main">
   <p:cSld>
     <p:spTree>
@@ -20099,8 +20460,8 @@
           </a:p>
         </p:txBody>
       </p:sp>
-      <mc:AlternateContent xmlns:mc="http://schemas.openxmlformats.org/markup-compatibility/2006">
-        <mc:Choice xmlns:a14="http://schemas.microsoft.com/office/drawing/2010/main" Requires="a14">
+      <mc:AlternateContent xmlns:mc="http://schemas.openxmlformats.org/markup-compatibility/2006" xmlns:a14="http://schemas.microsoft.com/office/drawing/2010/main">
+        <mc:Choice Requires="a14">
           <p:sp>
             <p:nvSpPr>
               <p:cNvPr id="8" name="CasellaDiTesto 7">
@@ -20217,7 +20578,9 @@
                 <a14:m>
                   <m:oMath xmlns:m="http://schemas.openxmlformats.org/officeDocument/2006/math">
                     <m:r>
-                      <a:rPr lang="it-IT" sz="2800" dirty="0"/>
+                      <a:rPr lang="it-IT" sz="2800" dirty="0">
+                        <a:latin typeface="Cambria Math" panose="02040503050406030204" pitchFamily="18" charset="0"/>
+                      </a:rPr>
                       <m:t>≈</m:t>
                     </m:r>
                   </m:oMath>
@@ -20231,12 +20594,16 @@
                     <m:f>
                       <m:fPr>
                         <m:ctrlPr>
-                          <a:rPr lang="it-IT" sz="2800" i="1"/>
+                          <a:rPr lang="it-IT" sz="2800" i="1">
+                            <a:latin typeface="Cambria Math" panose="02040503050406030204" pitchFamily="18" charset="0"/>
+                          </a:rPr>
                         </m:ctrlPr>
                       </m:fPr>
                       <m:num>
                         <m:r>
-                          <a:rPr lang="it-IT" sz="2800" i="1" dirty="0"/>
+                          <a:rPr lang="it-IT" sz="2800" i="1" dirty="0">
+                            <a:latin typeface="Cambria Math" panose="02040503050406030204" pitchFamily="18" charset="0"/>
+                          </a:rPr>
                           <m:t>𝜇</m:t>
                         </m:r>
                         <m:r>
@@ -20247,7 +20614,9 @@
                           <m:t> + 3 </m:t>
                         </m:r>
                         <m:r>
-                          <a:rPr lang="it-IT" sz="2800" i="1" dirty="0"/>
+                          <a:rPr lang="it-IT" sz="2800" i="1" dirty="0">
+                            <a:latin typeface="Cambria Math" panose="02040503050406030204" pitchFamily="18" charset="0"/>
+                          </a:rPr>
                           <m:t>𝜎</m:t>
                         </m:r>
                         <m:r>
@@ -20260,7 +20629,9 @@
                       </m:num>
                       <m:den>
                         <m:r>
-                          <a:rPr lang="it-IT" sz="2800" i="1" dirty="0"/>
+                          <a:rPr lang="it-IT" sz="2800" i="1" dirty="0">
+                            <a:latin typeface="Cambria Math" panose="02040503050406030204" pitchFamily="18" charset="0"/>
+                          </a:rPr>
                           <m:t>𝜇</m:t>
                         </m:r>
                       </m:den>
@@ -20316,7 +20687,7 @@
             </p:txBody>
           </p:sp>
         </mc:Choice>
-        <mc:Fallback>
+        <mc:Fallback xmlns="">
           <p:sp>
             <p:nvSpPr>
               <p:cNvPr id="8" name="CasellaDiTesto 7">
@@ -20396,7 +20767,7 @@
                   <a:schemeClr val="bg1"/>
                 </a:solidFill>
               </a:rPr>
-              <a:t>41</a:t>
+              <a:t>54</a:t>
             </a:r>
           </a:p>
         </p:txBody>
@@ -20405,309 +20776,6 @@
     <p:extLst>
       <p:ext uri="{BB962C8B-B14F-4D97-AF65-F5344CB8AC3E}">
         <p14:creationId xmlns:p14="http://schemas.microsoft.com/office/powerpoint/2010/main" val="3204728833"/>
-      </p:ext>
-    </p:extLst>
-  </p:cSld>
-  <p:clrMapOvr>
-    <a:masterClrMapping/>
-  </p:clrMapOvr>
-  <mc:AlternateContent xmlns:mc="http://schemas.openxmlformats.org/markup-compatibility/2006" xmlns:p159="http://schemas.microsoft.com/office/powerpoint/2015/09/main">
-    <mc:Choice Requires="p159">
-      <p:transition xmlns:p14="http://schemas.microsoft.com/office/powerpoint/2010/main" spd="slow" p14:dur="2000">
-        <p159:morph option="byObject"/>
-      </p:transition>
-    </mc:Choice>
-    <mc:Fallback xmlns="">
-      <p:transition spd="slow">
-        <p:fade/>
-      </p:transition>
-    </mc:Fallback>
-  </mc:AlternateContent>
-</p:sld>
-</file>
-
-<file path=ppt/slides/slide56.xml><?xml version="1.0" encoding="utf-8"?>
-<p:sld xmlns:a="http://schemas.openxmlformats.org/drawingml/2006/main" xmlns:r="http://schemas.openxmlformats.org/officeDocument/2006/relationships" xmlns:p="http://schemas.openxmlformats.org/presentationml/2006/main">
-  <p:cSld>
-    <p:spTree>
-      <p:nvGrpSpPr>
-        <p:cNvPr id="1" name="">
-          <a:extLst>
-            <a:ext uri="{FF2B5EF4-FFF2-40B4-BE49-F238E27FC236}">
-              <a16:creationId xmlns:a16="http://schemas.microsoft.com/office/drawing/2014/main" id="{BC703C0D-6076-EDDA-DA62-3FFD560D3070}"/>
-            </a:ext>
-          </a:extLst>
-        </p:cNvPr>
-        <p:cNvGrpSpPr/>
-        <p:nvPr/>
-      </p:nvGrpSpPr>
-      <p:grpSpPr>
-        <a:xfrm>
-          <a:off x="0" y="0"/>
-          <a:ext cx="0" cy="0"/>
-          <a:chOff x="0" y="0"/>
-          <a:chExt cx="0" cy="0"/>
-        </a:xfrm>
-      </p:grpSpPr>
-      <p:sp>
-        <p:nvSpPr>
-          <p:cNvPr id="5" name="Rettangolo 4">
-            <a:extLst>
-              <a:ext uri="{FF2B5EF4-FFF2-40B4-BE49-F238E27FC236}">
-                <a16:creationId xmlns:a16="http://schemas.microsoft.com/office/drawing/2014/main" id="{20DA4FF2-7B5D-EDBE-99E5-1CC39E1E32F6}"/>
-              </a:ext>
-            </a:extLst>
-          </p:cNvPr>
-          <p:cNvSpPr/>
-          <p:nvPr/>
-        </p:nvSpPr>
-        <p:spPr>
-          <a:xfrm rot="16200000">
-            <a:off x="5612871" y="326546"/>
-            <a:ext cx="966258" cy="12192000"/>
-          </a:xfrm>
-          <a:prstGeom prst="rect">
-            <a:avLst/>
-          </a:prstGeom>
-          <a:solidFill>
-            <a:srgbClr val="990000"/>
-          </a:solidFill>
-          <a:ln>
-            <a:solidFill>
-              <a:srgbClr val="990000"/>
-            </a:solidFill>
-          </a:ln>
-        </p:spPr>
-        <p:style>
-          <a:lnRef idx="2">
-            <a:schemeClr val="accent1">
-              <a:shade val="15000"/>
-            </a:schemeClr>
-          </a:lnRef>
-          <a:fillRef idx="1">
-            <a:schemeClr val="accent1"/>
-          </a:fillRef>
-          <a:effectRef idx="0">
-            <a:schemeClr val="accent1"/>
-          </a:effectRef>
-          <a:fontRef idx="minor">
-            <a:schemeClr val="lt1"/>
-          </a:fontRef>
-        </p:style>
-        <p:txBody>
-          <a:bodyPr rtlCol="0" anchor="ctr"/>
-          <a:lstStyle/>
-          <a:p>
-            <a:pPr algn="ctr"/>
-            <a:endParaRPr lang="it-IT" dirty="0"/>
-          </a:p>
-        </p:txBody>
-      </p:sp>
-      <p:sp>
-        <p:nvSpPr>
-          <p:cNvPr id="6" name="CasellaDiTesto 5">
-            <a:extLst>
-              <a:ext uri="{FF2B5EF4-FFF2-40B4-BE49-F238E27FC236}">
-                <a16:creationId xmlns:a16="http://schemas.microsoft.com/office/drawing/2014/main" id="{2A63AD9D-B169-C12A-2A0C-144AF23F63FC}"/>
-              </a:ext>
-            </a:extLst>
-          </p:cNvPr>
-          <p:cNvSpPr txBox="1"/>
-          <p:nvPr/>
-        </p:nvSpPr>
-        <p:spPr>
-          <a:xfrm>
-            <a:off x="5086139" y="6222490"/>
-            <a:ext cx="2019720" cy="400110"/>
-          </a:xfrm>
-          <a:prstGeom prst="rect">
-            <a:avLst/>
-          </a:prstGeom>
-          <a:noFill/>
-        </p:spPr>
-        <p:txBody>
-          <a:bodyPr wrap="square" rtlCol="0">
-            <a:spAutoFit/>
-          </a:bodyPr>
-          <a:lstStyle/>
-          <a:p>
-            <a:pPr algn="r"/>
-            <a:r>
-              <a:rPr lang="it-IT" sz="2000" b="1" dirty="0">
-                <a:solidFill>
-                  <a:schemeClr val="bg1"/>
-                </a:solidFill>
-              </a:rPr>
-              <a:t>Gianpaolo Pestilli</a:t>
-            </a:r>
-          </a:p>
-        </p:txBody>
-      </p:sp>
-      <p:sp>
-        <p:nvSpPr>
-          <p:cNvPr id="8" name="CasellaDiTesto 7">
-            <a:extLst>
-              <a:ext uri="{FF2B5EF4-FFF2-40B4-BE49-F238E27FC236}">
-                <a16:creationId xmlns:a16="http://schemas.microsoft.com/office/drawing/2014/main" id="{D028465C-1A6E-7D80-5C6C-3E04F17A1A6B}"/>
-              </a:ext>
-            </a:extLst>
-          </p:cNvPr>
-          <p:cNvSpPr txBox="1"/>
-          <p:nvPr/>
-        </p:nvSpPr>
-        <p:spPr>
-          <a:xfrm>
-            <a:off x="533399" y="728069"/>
-            <a:ext cx="11116884" cy="5032147"/>
-          </a:xfrm>
-          <a:prstGeom prst="rect">
-            <a:avLst/>
-          </a:prstGeom>
-          <a:noFill/>
-        </p:spPr>
-        <p:txBody>
-          <a:bodyPr wrap="square" rtlCol="0">
-            <a:spAutoFit/>
-          </a:bodyPr>
-          <a:lstStyle/>
-          <a:p>
-            <a:pPr algn="just">
-              <a:spcAft>
-                <a:spcPts val="600"/>
-              </a:spcAft>
-            </a:pPr>
-            <a:r>
-              <a:rPr lang="it-IT" sz="4000" b="1" dirty="0">
-                <a:solidFill>
-                  <a:srgbClr val="990000"/>
-                </a:solidFill>
-              </a:rPr>
-              <a:t>GENERAZIONE DELLE ISTANZE</a:t>
-            </a:r>
-          </a:p>
-          <a:p>
-            <a:pPr algn="just">
-              <a:spcAft>
-                <a:spcPts val="600"/>
-              </a:spcAft>
-            </a:pPr>
-            <a:r>
-              <a:rPr lang="it-IT" sz="3200" b="1" dirty="0"/>
-              <a:t>Vertex cover non pesato – Istruzioni che vale la pena commentare:</a:t>
-            </a:r>
-          </a:p>
-          <a:p>
-            <a:pPr algn="just">
-              <a:spcAft>
-                <a:spcPts val="600"/>
-              </a:spcAft>
-            </a:pPr>
-            <a:endParaRPr lang="it-IT" sz="3200" b="1" dirty="0"/>
-          </a:p>
-          <a:p>
-            <a:pPr algn="just">
-              <a:spcAft>
-                <a:spcPts val="600"/>
-              </a:spcAft>
-            </a:pPr>
-            <a:endParaRPr lang="it-IT" sz="3200" b="1" dirty="0"/>
-          </a:p>
-          <a:p>
-            <a:pPr algn="just">
-              <a:spcAft>
-                <a:spcPts val="600"/>
-              </a:spcAft>
-            </a:pPr>
-            <a:endParaRPr lang="it-IT" sz="3200" b="1" dirty="0"/>
-          </a:p>
-          <a:p>
-            <a:pPr algn="just">
-              <a:spcAft>
-                <a:spcPts val="600"/>
-              </a:spcAft>
-            </a:pPr>
-            <a:r>
-              <a:rPr lang="it-IT" sz="3200" dirty="0"/>
-              <a:t>Si utilizza una normale perché è una variabile aleatoria la cui varianza non si ottiene in modo matematico a partire dalla media (si può modificare a piacimento mantenendo la media fissa).</a:t>
-            </a:r>
-          </a:p>
-        </p:txBody>
-      </p:sp>
-      <p:sp>
-        <p:nvSpPr>
-          <p:cNvPr id="2" name="CasellaDiTesto 1">
-            <a:extLst>
-              <a:ext uri="{FF2B5EF4-FFF2-40B4-BE49-F238E27FC236}">
-                <a16:creationId xmlns:a16="http://schemas.microsoft.com/office/drawing/2014/main" id="{BB63DFD3-C9E3-9EFF-F47F-CFF1391A6858}"/>
-              </a:ext>
-            </a:extLst>
-          </p:cNvPr>
-          <p:cNvSpPr txBox="1"/>
-          <p:nvPr/>
-        </p:nvSpPr>
-        <p:spPr>
-          <a:xfrm>
-            <a:off x="11434917" y="6222490"/>
-            <a:ext cx="491612" cy="400110"/>
-          </a:xfrm>
-          <a:prstGeom prst="rect">
-            <a:avLst/>
-          </a:prstGeom>
-          <a:noFill/>
-        </p:spPr>
-        <p:txBody>
-          <a:bodyPr wrap="square" rtlCol="0">
-            <a:spAutoFit/>
-          </a:bodyPr>
-          <a:lstStyle/>
-          <a:p>
-            <a:pPr algn="r"/>
-            <a:r>
-              <a:rPr lang="it-IT" sz="2000" b="1" dirty="0">
-                <a:solidFill>
-                  <a:schemeClr val="bg1"/>
-                </a:solidFill>
-              </a:rPr>
-              <a:t>41</a:t>
-            </a:r>
-          </a:p>
-        </p:txBody>
-      </p:sp>
-      <p:pic>
-        <p:nvPicPr>
-          <p:cNvPr id="7" name="Immagine 6">
-            <a:extLst>
-              <a:ext uri="{FF2B5EF4-FFF2-40B4-BE49-F238E27FC236}">
-                <a16:creationId xmlns:a16="http://schemas.microsoft.com/office/drawing/2014/main" id="{C1D6FA59-3C57-891A-8CE1-008016D91F4A}"/>
-              </a:ext>
-            </a:extLst>
-          </p:cNvPr>
-          <p:cNvPicPr>
-            <a:picLocks noChangeAspect="1"/>
-          </p:cNvPicPr>
-          <p:nvPr/>
-        </p:nvPicPr>
-        <p:blipFill>
-          <a:blip r:embed="rId2"/>
-          <a:srcRect t="47356" b="5339"/>
-          <a:stretch>
-            <a:fillRect/>
-          </a:stretch>
-        </p:blipFill>
-        <p:spPr>
-          <a:xfrm>
-            <a:off x="533399" y="2445773"/>
-            <a:ext cx="8708924" cy="1785979"/>
-          </a:xfrm>
-          <a:prstGeom prst="rect">
-            <a:avLst/>
-          </a:prstGeom>
-        </p:spPr>
-      </p:pic>
-    </p:spTree>
-    <p:extLst>
-      <p:ext uri="{BB962C8B-B14F-4D97-AF65-F5344CB8AC3E}">
-        <p14:creationId xmlns:p14="http://schemas.microsoft.com/office/powerpoint/2010/main" val="2990189964"/>
       </p:ext>
     </p:extLst>
   </p:cSld>
@@ -20971,17 +21039,17 @@
                   <a:schemeClr val="bg1"/>
                 </a:solidFill>
               </a:rPr>
-              <a:t>41</a:t>
+              <a:t>55</a:t>
             </a:r>
           </a:p>
         </p:txBody>
       </p:sp>
       <p:pic>
         <p:nvPicPr>
-          <p:cNvPr id="4" name="Immagine 3">
-            <a:extLst>
-              <a:ext uri="{FF2B5EF4-FFF2-40B4-BE49-F238E27FC236}">
-                <a16:creationId xmlns:a16="http://schemas.microsoft.com/office/drawing/2014/main" id="{AC112F92-E2B2-5244-04DB-953F9DADC309}"/>
+          <p:cNvPr id="3" name="Immagine 2">
+            <a:extLst>
+              <a:ext uri="{FF2B5EF4-FFF2-40B4-BE49-F238E27FC236}">
+                <a16:creationId xmlns:a16="http://schemas.microsoft.com/office/drawing/2014/main" id="{B83BE23E-BF05-CA6D-375F-E427BDA7612B}"/>
               </a:ext>
             </a:extLst>
           </p:cNvPr>
@@ -20992,15 +21060,15 @@
         </p:nvPicPr>
         <p:blipFill>
           <a:blip r:embed="rId2"/>
-          <a:srcRect t="29532" b="42032"/>
+          <a:srcRect t="47356" b="5339"/>
           <a:stretch>
             <a:fillRect/>
           </a:stretch>
         </p:blipFill>
         <p:spPr>
           <a:xfrm>
-            <a:off x="533399" y="2400026"/>
-            <a:ext cx="8958013" cy="1825177"/>
+            <a:off x="533399" y="2445773"/>
+            <a:ext cx="8708924" cy="1785979"/>
           </a:xfrm>
           <a:prstGeom prst="rect">
             <a:avLst/>
@@ -21149,61 +21217,166 @@
           </a:p>
         </p:txBody>
       </p:sp>
-      <p:sp>
-        <p:nvSpPr>
-          <p:cNvPr id="8" name="CasellaDiTesto 7">
-            <a:extLst>
-              <a:ext uri="{FF2B5EF4-FFF2-40B4-BE49-F238E27FC236}">
-                <a16:creationId xmlns:a16="http://schemas.microsoft.com/office/drawing/2014/main" id="{83DB7FBF-CD28-FD5C-D5FA-07B80298E5EF}"/>
-              </a:ext>
-            </a:extLst>
-          </p:cNvPr>
-          <p:cNvSpPr txBox="1"/>
-          <p:nvPr/>
-        </p:nvSpPr>
-        <p:spPr>
-          <a:xfrm>
-            <a:off x="533399" y="728069"/>
-            <a:ext cx="11116884" cy="1769715"/>
-          </a:xfrm>
-          <a:prstGeom prst="rect">
-            <a:avLst/>
-          </a:prstGeom>
-          <a:noFill/>
-        </p:spPr>
-        <p:txBody>
-          <a:bodyPr wrap="square" rtlCol="0">
-            <a:spAutoFit/>
-          </a:bodyPr>
-          <a:lstStyle/>
-          <a:p>
-            <a:pPr algn="just">
-              <a:spcAft>
-                <a:spcPts val="600"/>
-              </a:spcAft>
-            </a:pPr>
-            <a:r>
-              <a:rPr lang="it-IT" sz="4000" b="1" dirty="0">
-                <a:solidFill>
-                  <a:srgbClr val="990000"/>
-                </a:solidFill>
-              </a:rPr>
-              <a:t>GENERAZIONE DELLE ISTANZE</a:t>
-            </a:r>
-          </a:p>
-          <a:p>
-            <a:pPr algn="just">
-              <a:spcAft>
-                <a:spcPts val="600"/>
-              </a:spcAft>
-            </a:pPr>
-            <a:r>
-              <a:rPr lang="it-IT" sz="3200" b="1" dirty="0"/>
-              <a:t>Vertex cover non pesato – Istruzioni che vale la pena commentare:</a:t>
-            </a:r>
-          </a:p>
-        </p:txBody>
-      </p:sp>
+      <mc:AlternateContent xmlns:mc="http://schemas.openxmlformats.org/markup-compatibility/2006">
+        <mc:Choice xmlns:a14="http://schemas.microsoft.com/office/drawing/2010/main" Requires="a14">
+          <p:sp>
+            <p:nvSpPr>
+              <p:cNvPr id="8" name="CasellaDiTesto 7">
+                <a:extLst>
+                  <a:ext uri="{FF2B5EF4-FFF2-40B4-BE49-F238E27FC236}">
+                    <a16:creationId xmlns:a16="http://schemas.microsoft.com/office/drawing/2014/main" id="{83DB7FBF-CD28-FD5C-D5FA-07B80298E5EF}"/>
+                  </a:ext>
+                </a:extLst>
+              </p:cNvPr>
+              <p:cNvSpPr txBox="1"/>
+              <p:nvPr/>
+            </p:nvSpPr>
+            <p:spPr>
+              <a:xfrm>
+                <a:off x="533399" y="728069"/>
+                <a:ext cx="11116884" cy="5139869"/>
+              </a:xfrm>
+              <a:prstGeom prst="rect">
+                <a:avLst/>
+              </a:prstGeom>
+              <a:noFill/>
+            </p:spPr>
+            <p:txBody>
+              <a:bodyPr wrap="square" rtlCol="0">
+                <a:spAutoFit/>
+              </a:bodyPr>
+              <a:lstStyle/>
+              <a:p>
+                <a:pPr algn="just">
+                  <a:spcAft>
+                    <a:spcPts val="600"/>
+                  </a:spcAft>
+                </a:pPr>
+                <a:r>
+                  <a:rPr lang="it-IT" sz="4000" b="1" dirty="0">
+                    <a:solidFill>
+                      <a:srgbClr val="990000"/>
+                    </a:solidFill>
+                  </a:rPr>
+                  <a:t>GENERAZIONE DELLE ISTANZE</a:t>
+                </a:r>
+              </a:p>
+              <a:p>
+                <a:pPr algn="just">
+                  <a:spcAft>
+                    <a:spcPts val="600"/>
+                  </a:spcAft>
+                </a:pPr>
+                <a:r>
+                  <a:rPr lang="it-IT" sz="3200" b="1" dirty="0"/>
+                  <a:t>Vertex cover non pesato – Istruzioni che vale la pena commentare:</a:t>
+                </a:r>
+              </a:p>
+              <a:p>
+                <a:pPr algn="just">
+                  <a:spcAft>
+                    <a:spcPts val="600"/>
+                  </a:spcAft>
+                </a:pPr>
+                <a:endParaRPr lang="it-IT" sz="3200" b="1" dirty="0"/>
+              </a:p>
+              <a:p>
+                <a:pPr algn="just">
+                  <a:spcAft>
+                    <a:spcPts val="600"/>
+                  </a:spcAft>
+                </a:pPr>
+                <a:endParaRPr lang="it-IT" sz="3200" b="1" dirty="0"/>
+              </a:p>
+              <a:p>
+                <a:pPr algn="just">
+                  <a:spcAft>
+                    <a:spcPts val="600"/>
+                  </a:spcAft>
+                </a:pPr>
+                <a:r>
+                  <a:rPr lang="it-IT" sz="2800" dirty="0"/>
+                  <a:t>Si usa una </a:t>
+                </a:r>
+                <a:r>
+                  <a:rPr lang="it-IT" sz="2800" dirty="0" err="1"/>
+                  <a:t>lognormale</a:t>
+                </a:r>
+                <a:r>
+                  <a:rPr lang="it-IT" sz="2800" dirty="0"/>
+                  <a:t> perché ha una heavy </a:t>
+                </a:r>
+                <a:r>
+                  <a:rPr lang="it-IT" sz="2800" dirty="0" err="1"/>
+                  <a:t>tail</a:t>
+                </a:r>
+                <a:r>
+                  <a:rPr lang="it-IT" sz="2800" dirty="0"/>
+                  <a:t> e permette di «sbilanciare» il grafo (alternando vertici di grado molto alto a vertici di grado molto basso). </a:t>
+                </a:r>
+                <a14:m>
+                  <m:oMath xmlns:m="http://schemas.openxmlformats.org/officeDocument/2006/math">
+                    <m:r>
+                      <a:rPr lang="it-IT" sz="2800" i="1" dirty="0">
+                        <a:latin typeface="Cambria Math" panose="02040503050406030204" pitchFamily="18" charset="0"/>
+                      </a:rPr>
+                      <m:t>𝜎</m:t>
+                    </m:r>
+                  </m:oMath>
+                </a14:m>
+                <a:r>
+                  <a:rPr lang="it-IT" sz="2800" dirty="0"/>
+                  <a:t> = 1 è stato ritenuto un valore coerente per evitare la formazione di pochissimi nodi con altissimo grado ma senza generare valori troppo simili a quelli di una normale.</a:t>
+                </a:r>
+              </a:p>
+            </p:txBody>
+          </p:sp>
+        </mc:Choice>
+        <mc:Fallback>
+          <p:sp>
+            <p:nvSpPr>
+              <p:cNvPr id="8" name="CasellaDiTesto 7">
+                <a:extLst>
+                  <a:ext uri="{FF2B5EF4-FFF2-40B4-BE49-F238E27FC236}">
+                    <a16:creationId xmlns:a16="http://schemas.microsoft.com/office/drawing/2014/main" id="{83DB7FBF-CD28-FD5C-D5FA-07B80298E5EF}"/>
+                  </a:ext>
+                </a:extLst>
+              </p:cNvPr>
+              <p:cNvSpPr txBox="1">
+                <a:spLocks noRot="1" noChangeAspect="1" noMove="1" noResize="1" noEditPoints="1" noAdjustHandles="1" noChangeArrowheads="1" noChangeShapeType="1" noTextEdit="1"/>
+              </p:cNvSpPr>
+              <p:nvPr/>
+            </p:nvSpPr>
+            <p:spPr>
+              <a:xfrm>
+                <a:off x="533399" y="728069"/>
+                <a:ext cx="11116884" cy="5139869"/>
+              </a:xfrm>
+              <a:prstGeom prst="rect">
+                <a:avLst/>
+              </a:prstGeom>
+              <a:blipFill>
+                <a:blip r:embed="rId2"/>
+                <a:stretch>
+                  <a:fillRect l="-1919" t="-2133" r="-1371" b="-2370"/>
+                </a:stretch>
+              </a:blipFill>
+            </p:spPr>
+            <p:txBody>
+              <a:bodyPr/>
+              <a:lstStyle/>
+              <a:p>
+                <a:r>
+                  <a:rPr lang="it-IT">
+                    <a:noFill/>
+                  </a:rPr>
+                  <a:t> </a:t>
+                </a:r>
+              </a:p>
+            </p:txBody>
+          </p:sp>
+        </mc:Fallback>
+      </mc:AlternateContent>
       <p:sp>
         <p:nvSpPr>
           <p:cNvPr id="2" name="CasellaDiTesto 1">
@@ -21239,7 +21412,7 @@
                   <a:schemeClr val="bg1"/>
                 </a:solidFill>
               </a:rPr>
-              <a:t>44</a:t>
+              <a:t>56</a:t>
             </a:r>
           </a:p>
         </p:txBody>
@@ -21259,16 +21432,16 @@
           <p:nvPr/>
         </p:nvPicPr>
         <p:blipFill>
-          <a:blip r:embed="rId2"/>
-          <a:srcRect t="57169" b="9599"/>
+          <a:blip r:embed="rId3"/>
+          <a:srcRect t="65609" b="21897"/>
           <a:stretch>
             <a:fillRect/>
           </a:stretch>
         </p:blipFill>
         <p:spPr>
           <a:xfrm>
-            <a:off x="533399" y="2562423"/>
-            <a:ext cx="10793496" cy="2570016"/>
+            <a:off x="533399" y="2462740"/>
+            <a:ext cx="10793496" cy="966260"/>
           </a:xfrm>
           <a:prstGeom prst="rect">
             <a:avLst/>
@@ -21528,7 +21701,7 @@
                   <a:schemeClr val="bg1"/>
                 </a:solidFill>
               </a:rPr>
-              <a:t>41</a:t>
+              <a:t>57</a:t>
             </a:r>
           </a:p>
         </p:txBody>
@@ -22199,7 +22372,7 @@
                   <a:schemeClr val="bg1"/>
                 </a:solidFill>
               </a:rPr>
-              <a:t>41</a:t>
+              <a:t>58</a:t>
             </a:r>
           </a:p>
         </p:txBody>
@@ -22208,6 +22381,873 @@
     <p:extLst>
       <p:ext uri="{BB962C8B-B14F-4D97-AF65-F5344CB8AC3E}">
         <p14:creationId xmlns:p14="http://schemas.microsoft.com/office/powerpoint/2010/main" val="2845642612"/>
+      </p:ext>
+    </p:extLst>
+  </p:cSld>
+  <p:clrMapOvr>
+    <a:masterClrMapping/>
+  </p:clrMapOvr>
+  <mc:AlternateContent xmlns:mc="http://schemas.openxmlformats.org/markup-compatibility/2006" xmlns:p159="http://schemas.microsoft.com/office/powerpoint/2015/09/main">
+    <mc:Choice Requires="p159">
+      <p:transition xmlns:p14="http://schemas.microsoft.com/office/powerpoint/2010/main" spd="slow" p14:dur="2000">
+        <p159:morph option="byObject"/>
+      </p:transition>
+    </mc:Choice>
+    <mc:Fallback xmlns="">
+      <p:transition spd="slow">
+        <p:fade/>
+      </p:transition>
+    </mc:Fallback>
+  </mc:AlternateContent>
+</p:sld>
+</file>
+
+<file path=ppt/slides/slide61.xml><?xml version="1.0" encoding="utf-8"?>
+<p:sld xmlns:a="http://schemas.openxmlformats.org/drawingml/2006/main" xmlns:r="http://schemas.openxmlformats.org/officeDocument/2006/relationships" xmlns:p="http://schemas.openxmlformats.org/presentationml/2006/main">
+  <p:cSld>
+    <p:spTree>
+      <p:nvGrpSpPr>
+        <p:cNvPr id="1" name="">
+          <a:extLst>
+            <a:ext uri="{FF2B5EF4-FFF2-40B4-BE49-F238E27FC236}">
+              <a16:creationId xmlns:a16="http://schemas.microsoft.com/office/drawing/2014/main" id="{030AFE9A-BCC8-70C1-496F-54B85336AD27}"/>
+            </a:ext>
+          </a:extLst>
+        </p:cNvPr>
+        <p:cNvGrpSpPr/>
+        <p:nvPr/>
+      </p:nvGrpSpPr>
+      <p:grpSpPr>
+        <a:xfrm>
+          <a:off x="0" y="0"/>
+          <a:ext cx="0" cy="0"/>
+          <a:chOff x="0" y="0"/>
+          <a:chExt cx="0" cy="0"/>
+        </a:xfrm>
+      </p:grpSpPr>
+      <p:sp>
+        <p:nvSpPr>
+          <p:cNvPr id="5" name="Rettangolo 4">
+            <a:extLst>
+              <a:ext uri="{FF2B5EF4-FFF2-40B4-BE49-F238E27FC236}">
+                <a16:creationId xmlns:a16="http://schemas.microsoft.com/office/drawing/2014/main" id="{3820DDA9-78A9-0ABF-27D4-33F55C4EE0C0}"/>
+              </a:ext>
+            </a:extLst>
+          </p:cNvPr>
+          <p:cNvSpPr/>
+          <p:nvPr/>
+        </p:nvSpPr>
+        <p:spPr>
+          <a:xfrm rot="16200000">
+            <a:off x="5612871" y="326546"/>
+            <a:ext cx="966258" cy="12192000"/>
+          </a:xfrm>
+          <a:prstGeom prst="rect">
+            <a:avLst/>
+          </a:prstGeom>
+          <a:solidFill>
+            <a:srgbClr val="990000"/>
+          </a:solidFill>
+          <a:ln>
+            <a:solidFill>
+              <a:srgbClr val="990000"/>
+            </a:solidFill>
+          </a:ln>
+        </p:spPr>
+        <p:style>
+          <a:lnRef idx="2">
+            <a:schemeClr val="accent1">
+              <a:shade val="15000"/>
+            </a:schemeClr>
+          </a:lnRef>
+          <a:fillRef idx="1">
+            <a:schemeClr val="accent1"/>
+          </a:fillRef>
+          <a:effectRef idx="0">
+            <a:schemeClr val="accent1"/>
+          </a:effectRef>
+          <a:fontRef idx="minor">
+            <a:schemeClr val="lt1"/>
+          </a:fontRef>
+        </p:style>
+        <p:txBody>
+          <a:bodyPr rtlCol="0" anchor="ctr"/>
+          <a:lstStyle/>
+          <a:p>
+            <a:pPr algn="ctr"/>
+            <a:endParaRPr lang="it-IT" dirty="0"/>
+          </a:p>
+        </p:txBody>
+      </p:sp>
+      <p:sp>
+        <p:nvSpPr>
+          <p:cNvPr id="6" name="CasellaDiTesto 5">
+            <a:extLst>
+              <a:ext uri="{FF2B5EF4-FFF2-40B4-BE49-F238E27FC236}">
+                <a16:creationId xmlns:a16="http://schemas.microsoft.com/office/drawing/2014/main" id="{7ECC10BB-DD57-0ABC-E3E8-FF4533EBF85B}"/>
+              </a:ext>
+            </a:extLst>
+          </p:cNvPr>
+          <p:cNvSpPr txBox="1"/>
+          <p:nvPr/>
+        </p:nvSpPr>
+        <p:spPr>
+          <a:xfrm>
+            <a:off x="5086139" y="6222490"/>
+            <a:ext cx="2019720" cy="400110"/>
+          </a:xfrm>
+          <a:prstGeom prst="rect">
+            <a:avLst/>
+          </a:prstGeom>
+          <a:noFill/>
+        </p:spPr>
+        <p:txBody>
+          <a:bodyPr wrap="square" rtlCol="0">
+            <a:spAutoFit/>
+          </a:bodyPr>
+          <a:lstStyle/>
+          <a:p>
+            <a:pPr algn="r"/>
+            <a:r>
+              <a:rPr lang="it-IT" sz="2000" b="1" dirty="0">
+                <a:solidFill>
+                  <a:schemeClr val="bg1"/>
+                </a:solidFill>
+              </a:rPr>
+              <a:t>Gianpaolo Pestilli</a:t>
+            </a:r>
+          </a:p>
+        </p:txBody>
+      </p:sp>
+      <p:sp>
+        <p:nvSpPr>
+          <p:cNvPr id="8" name="CasellaDiTesto 7">
+            <a:extLst>
+              <a:ext uri="{FF2B5EF4-FFF2-40B4-BE49-F238E27FC236}">
+                <a16:creationId xmlns:a16="http://schemas.microsoft.com/office/drawing/2014/main" id="{FDA3B9C9-BFB8-5291-FB1C-266AC197D900}"/>
+              </a:ext>
+            </a:extLst>
+          </p:cNvPr>
+          <p:cNvSpPr txBox="1"/>
+          <p:nvPr/>
+        </p:nvSpPr>
+        <p:spPr>
+          <a:xfrm>
+            <a:off x="533399" y="728069"/>
+            <a:ext cx="11116884" cy="4955203"/>
+          </a:xfrm>
+          <a:prstGeom prst="rect">
+            <a:avLst/>
+          </a:prstGeom>
+          <a:noFill/>
+        </p:spPr>
+        <p:txBody>
+          <a:bodyPr wrap="square" rtlCol="0">
+            <a:spAutoFit/>
+          </a:bodyPr>
+          <a:lstStyle/>
+          <a:p>
+            <a:pPr algn="just">
+              <a:spcAft>
+                <a:spcPts val="600"/>
+              </a:spcAft>
+            </a:pPr>
+            <a:r>
+              <a:rPr lang="it-IT" sz="4000" b="1" dirty="0">
+                <a:solidFill>
+                  <a:srgbClr val="990000"/>
+                </a:solidFill>
+              </a:rPr>
+              <a:t>ESECUZIONE</a:t>
+            </a:r>
+          </a:p>
+          <a:p>
+            <a:pPr algn="just">
+              <a:spcAft>
+                <a:spcPts val="600"/>
+              </a:spcAft>
+            </a:pPr>
+            <a:r>
+              <a:rPr lang="it-IT" sz="3200" b="1" dirty="0"/>
+              <a:t>Classi di istanze da testare: </a:t>
+            </a:r>
+            <a:r>
+              <a:rPr lang="it-IT" sz="3200" dirty="0"/>
+              <a:t>incrociando i criteri di partizionamento precedentemente definiti (densità, eterogeneità del grado, ecc.), si ottengono per combinazione tutte le classi di test oggetto del progetto.</a:t>
+            </a:r>
+          </a:p>
+          <a:p>
+            <a:pPr algn="just">
+              <a:spcAft>
+                <a:spcPts val="600"/>
+              </a:spcAft>
+            </a:pPr>
+            <a:r>
+              <a:rPr lang="it-IT" sz="3200" b="1" dirty="0"/>
+              <a:t>Numero di </a:t>
+            </a:r>
+            <a:r>
+              <a:rPr lang="it-IT" sz="3200" b="1" dirty="0" err="1"/>
+              <a:t>run</a:t>
+            </a:r>
+            <a:r>
+              <a:rPr lang="it-IT" sz="3200" b="1" dirty="0"/>
+              <a:t>: </a:t>
+            </a:r>
+            <a:r>
+              <a:rPr lang="it-IT" sz="3200" dirty="0"/>
+              <a:t>per ogni classe sono stati generate 15 istanze.</a:t>
+            </a:r>
+          </a:p>
+          <a:p>
+            <a:pPr algn="just">
+              <a:spcAft>
+                <a:spcPts val="600"/>
+              </a:spcAft>
+            </a:pPr>
+            <a:r>
+              <a:rPr lang="it-IT" sz="3200" b="1" dirty="0"/>
+              <a:t>Solver scelto: </a:t>
+            </a:r>
+            <a:r>
+              <a:rPr lang="it-IT" sz="3200" dirty="0" err="1"/>
+              <a:t>Gurobi</a:t>
+            </a:r>
+            <a:r>
+              <a:rPr lang="it-IT" sz="3200" dirty="0"/>
+              <a:t> con licenza accademica (ritenuto il migliore per problemi relativi ai grafi).</a:t>
+            </a:r>
+          </a:p>
+          <a:p>
+            <a:pPr algn="just">
+              <a:spcAft>
+                <a:spcPts val="600"/>
+              </a:spcAft>
+            </a:pPr>
+            <a:r>
+              <a:rPr lang="it-IT" sz="3200" b="1" dirty="0"/>
+              <a:t>Tempo di </a:t>
+            </a:r>
+            <a:r>
+              <a:rPr lang="it-IT" sz="3200" b="1" dirty="0" err="1"/>
+              <a:t>timeout</a:t>
+            </a:r>
+            <a:r>
+              <a:rPr lang="it-IT" sz="3200" b="1" dirty="0"/>
+              <a:t>: </a:t>
+            </a:r>
+            <a:r>
+              <a:rPr lang="it-IT" sz="3200" dirty="0"/>
+              <a:t>300 secondi.</a:t>
+            </a:r>
+            <a:endParaRPr lang="it-IT" sz="3200" b="1" dirty="0"/>
+          </a:p>
+        </p:txBody>
+      </p:sp>
+      <p:sp>
+        <p:nvSpPr>
+          <p:cNvPr id="2" name="CasellaDiTesto 1">
+            <a:extLst>
+              <a:ext uri="{FF2B5EF4-FFF2-40B4-BE49-F238E27FC236}">
+                <a16:creationId xmlns:a16="http://schemas.microsoft.com/office/drawing/2014/main" id="{02010BFE-F1F0-B80A-85F5-0DD977A3E3E2}"/>
+              </a:ext>
+            </a:extLst>
+          </p:cNvPr>
+          <p:cNvSpPr txBox="1"/>
+          <p:nvPr/>
+        </p:nvSpPr>
+        <p:spPr>
+          <a:xfrm>
+            <a:off x="11434917" y="6222490"/>
+            <a:ext cx="491612" cy="400110"/>
+          </a:xfrm>
+          <a:prstGeom prst="rect">
+            <a:avLst/>
+          </a:prstGeom>
+          <a:noFill/>
+        </p:spPr>
+        <p:txBody>
+          <a:bodyPr wrap="square" rtlCol="0">
+            <a:spAutoFit/>
+          </a:bodyPr>
+          <a:lstStyle/>
+          <a:p>
+            <a:pPr algn="r"/>
+            <a:r>
+              <a:rPr lang="it-IT" sz="2000" b="1" dirty="0">
+                <a:solidFill>
+                  <a:schemeClr val="bg1"/>
+                </a:solidFill>
+              </a:rPr>
+              <a:t>59</a:t>
+            </a:r>
+          </a:p>
+        </p:txBody>
+      </p:sp>
+    </p:spTree>
+    <p:extLst>
+      <p:ext uri="{BB962C8B-B14F-4D97-AF65-F5344CB8AC3E}">
+        <p14:creationId xmlns:p14="http://schemas.microsoft.com/office/powerpoint/2010/main" val="1059840757"/>
+      </p:ext>
+    </p:extLst>
+  </p:cSld>
+  <p:clrMapOvr>
+    <a:masterClrMapping/>
+  </p:clrMapOvr>
+  <mc:AlternateContent xmlns:mc="http://schemas.openxmlformats.org/markup-compatibility/2006" xmlns:p159="http://schemas.microsoft.com/office/powerpoint/2015/09/main">
+    <mc:Choice Requires="p159">
+      <p:transition xmlns:p14="http://schemas.microsoft.com/office/powerpoint/2010/main" spd="slow" p14:dur="2000">
+        <p159:morph option="byObject"/>
+      </p:transition>
+    </mc:Choice>
+    <mc:Fallback xmlns="">
+      <p:transition spd="slow">
+        <p:fade/>
+      </p:transition>
+    </mc:Fallback>
+  </mc:AlternateContent>
+</p:sld>
+</file>
+
+<file path=ppt/slides/slide62.xml><?xml version="1.0" encoding="utf-8"?>
+<p:sld xmlns:a="http://schemas.openxmlformats.org/drawingml/2006/main" xmlns:r="http://schemas.openxmlformats.org/officeDocument/2006/relationships" xmlns:p="http://schemas.openxmlformats.org/presentationml/2006/main">
+  <p:cSld>
+    <p:spTree>
+      <p:nvGrpSpPr>
+        <p:cNvPr id="1" name="">
+          <a:extLst>
+            <a:ext uri="{FF2B5EF4-FFF2-40B4-BE49-F238E27FC236}">
+              <a16:creationId xmlns:a16="http://schemas.microsoft.com/office/drawing/2014/main" id="{9733D5EB-EF7B-B42C-69A7-AED0A5595D05}"/>
+            </a:ext>
+          </a:extLst>
+        </p:cNvPr>
+        <p:cNvGrpSpPr/>
+        <p:nvPr/>
+      </p:nvGrpSpPr>
+      <p:grpSpPr>
+        <a:xfrm>
+          <a:off x="0" y="0"/>
+          <a:ext cx="0" cy="0"/>
+          <a:chOff x="0" y="0"/>
+          <a:chExt cx="0" cy="0"/>
+        </a:xfrm>
+      </p:grpSpPr>
+      <p:sp>
+        <p:nvSpPr>
+          <p:cNvPr id="5" name="Rettangolo 4">
+            <a:extLst>
+              <a:ext uri="{FF2B5EF4-FFF2-40B4-BE49-F238E27FC236}">
+                <a16:creationId xmlns:a16="http://schemas.microsoft.com/office/drawing/2014/main" id="{E45B9468-C1AC-3F27-EB52-EB26565F6EFE}"/>
+              </a:ext>
+            </a:extLst>
+          </p:cNvPr>
+          <p:cNvSpPr/>
+          <p:nvPr/>
+        </p:nvSpPr>
+        <p:spPr>
+          <a:xfrm rot="16200000">
+            <a:off x="5612871" y="326546"/>
+            <a:ext cx="966258" cy="12192000"/>
+          </a:xfrm>
+          <a:prstGeom prst="rect">
+            <a:avLst/>
+          </a:prstGeom>
+          <a:solidFill>
+            <a:srgbClr val="990000"/>
+          </a:solidFill>
+          <a:ln>
+            <a:solidFill>
+              <a:srgbClr val="990000"/>
+            </a:solidFill>
+          </a:ln>
+        </p:spPr>
+        <p:style>
+          <a:lnRef idx="2">
+            <a:schemeClr val="accent1">
+              <a:shade val="15000"/>
+            </a:schemeClr>
+          </a:lnRef>
+          <a:fillRef idx="1">
+            <a:schemeClr val="accent1"/>
+          </a:fillRef>
+          <a:effectRef idx="0">
+            <a:schemeClr val="accent1"/>
+          </a:effectRef>
+          <a:fontRef idx="minor">
+            <a:schemeClr val="lt1"/>
+          </a:fontRef>
+        </p:style>
+        <p:txBody>
+          <a:bodyPr rtlCol="0" anchor="ctr"/>
+          <a:lstStyle/>
+          <a:p>
+            <a:pPr algn="ctr"/>
+            <a:endParaRPr lang="it-IT" dirty="0"/>
+          </a:p>
+        </p:txBody>
+      </p:sp>
+      <p:sp>
+        <p:nvSpPr>
+          <p:cNvPr id="6" name="CasellaDiTesto 5">
+            <a:extLst>
+              <a:ext uri="{FF2B5EF4-FFF2-40B4-BE49-F238E27FC236}">
+                <a16:creationId xmlns:a16="http://schemas.microsoft.com/office/drawing/2014/main" id="{26DFD405-25E8-BFFF-24BB-DD64D4D83813}"/>
+              </a:ext>
+            </a:extLst>
+          </p:cNvPr>
+          <p:cNvSpPr txBox="1"/>
+          <p:nvPr/>
+        </p:nvSpPr>
+        <p:spPr>
+          <a:xfrm>
+            <a:off x="5086139" y="6222490"/>
+            <a:ext cx="2019720" cy="400110"/>
+          </a:xfrm>
+          <a:prstGeom prst="rect">
+            <a:avLst/>
+          </a:prstGeom>
+          <a:noFill/>
+        </p:spPr>
+        <p:txBody>
+          <a:bodyPr wrap="square" rtlCol="0">
+            <a:spAutoFit/>
+          </a:bodyPr>
+          <a:lstStyle/>
+          <a:p>
+            <a:pPr algn="r"/>
+            <a:r>
+              <a:rPr lang="it-IT" sz="2000" b="1" dirty="0">
+                <a:solidFill>
+                  <a:schemeClr val="bg1"/>
+                </a:solidFill>
+              </a:rPr>
+              <a:t>Gianpaolo Pestilli</a:t>
+            </a:r>
+          </a:p>
+        </p:txBody>
+      </p:sp>
+      <p:sp>
+        <p:nvSpPr>
+          <p:cNvPr id="8" name="CasellaDiTesto 7">
+            <a:extLst>
+              <a:ext uri="{FF2B5EF4-FFF2-40B4-BE49-F238E27FC236}">
+                <a16:creationId xmlns:a16="http://schemas.microsoft.com/office/drawing/2014/main" id="{E9C5482D-671B-017A-9987-1A9C9FF6E3DF}"/>
+              </a:ext>
+            </a:extLst>
+          </p:cNvPr>
+          <p:cNvSpPr txBox="1"/>
+          <p:nvPr/>
+        </p:nvSpPr>
+        <p:spPr>
+          <a:xfrm>
+            <a:off x="533399" y="728069"/>
+            <a:ext cx="11116884" cy="4385816"/>
+          </a:xfrm>
+          <a:prstGeom prst="rect">
+            <a:avLst/>
+          </a:prstGeom>
+          <a:noFill/>
+        </p:spPr>
+        <p:txBody>
+          <a:bodyPr wrap="square" rtlCol="0">
+            <a:spAutoFit/>
+          </a:bodyPr>
+          <a:lstStyle/>
+          <a:p>
+            <a:pPr algn="just">
+              <a:spcAft>
+                <a:spcPts val="600"/>
+              </a:spcAft>
+            </a:pPr>
+            <a:r>
+              <a:rPr lang="it-IT" sz="4000" b="1" dirty="0">
+                <a:solidFill>
+                  <a:srgbClr val="990000"/>
+                </a:solidFill>
+              </a:rPr>
+              <a:t>ASSUNZIONI</a:t>
+            </a:r>
+          </a:p>
+          <a:p>
+            <a:pPr algn="just">
+              <a:spcAft>
+                <a:spcPts val="600"/>
+              </a:spcAft>
+            </a:pPr>
+            <a:r>
+              <a:rPr lang="it-IT" sz="3200" b="1" dirty="0"/>
+              <a:t>Risultati effettivamente riportati: </a:t>
+            </a:r>
+            <a:r>
+              <a:rPr lang="it-IT" sz="3200" dirty="0"/>
+              <a:t>di seguito solo i risultati più interessanti osservati su 30 classi.</a:t>
+            </a:r>
+          </a:p>
+          <a:p>
+            <a:pPr algn="just">
+              <a:spcAft>
+                <a:spcPts val="600"/>
+              </a:spcAft>
+            </a:pPr>
+            <a:endParaRPr lang="it-IT" sz="3200" b="1" dirty="0"/>
+          </a:p>
+          <a:p>
+            <a:pPr algn="just">
+              <a:spcAft>
+                <a:spcPts val="600"/>
+              </a:spcAft>
+            </a:pPr>
+            <a:r>
+              <a:rPr lang="it-IT" sz="3200" b="1" dirty="0"/>
+              <a:t>Risoluzione del </a:t>
+            </a:r>
+            <a:r>
+              <a:rPr lang="it-IT" sz="3200" b="1" dirty="0" err="1"/>
+              <a:t>timeout</a:t>
+            </a:r>
+            <a:r>
+              <a:rPr lang="it-IT" sz="3200" b="1" dirty="0"/>
+              <a:t>: </a:t>
+            </a:r>
+            <a:r>
+              <a:rPr lang="it-IT" sz="3200" dirty="0"/>
+              <a:t>se il solver va in </a:t>
+            </a:r>
+            <a:r>
+              <a:rPr lang="it-IT" sz="3200" dirty="0" err="1"/>
+              <a:t>timeout</a:t>
+            </a:r>
+            <a:r>
+              <a:rPr lang="it-IT" sz="3200" dirty="0"/>
+              <a:t> prima di trovare l’ottimo, si seleziona il miglior </a:t>
+            </a:r>
+            <a:r>
+              <a:rPr lang="it-IT" sz="3200" dirty="0" err="1"/>
+              <a:t>lower</a:t>
+            </a:r>
+            <a:r>
+              <a:rPr lang="it-IT" sz="3200" dirty="0"/>
+              <a:t> </a:t>
+            </a:r>
+            <a:r>
+              <a:rPr lang="it-IT" sz="3200" dirty="0" err="1"/>
+              <a:t>bound</a:t>
+            </a:r>
+            <a:r>
+              <a:rPr lang="it-IT" sz="3200" dirty="0"/>
+              <a:t> trovato fino a quel momento e si usa per calcolare il rapporto di approssimazione.</a:t>
+            </a:r>
+            <a:endParaRPr lang="it-IT" sz="3200" b="1" dirty="0"/>
+          </a:p>
+        </p:txBody>
+      </p:sp>
+      <p:sp>
+        <p:nvSpPr>
+          <p:cNvPr id="2" name="CasellaDiTesto 1">
+            <a:extLst>
+              <a:ext uri="{FF2B5EF4-FFF2-40B4-BE49-F238E27FC236}">
+                <a16:creationId xmlns:a16="http://schemas.microsoft.com/office/drawing/2014/main" id="{15E4C33C-FB28-CF64-1D70-D12796DBEE6E}"/>
+              </a:ext>
+            </a:extLst>
+          </p:cNvPr>
+          <p:cNvSpPr txBox="1"/>
+          <p:nvPr/>
+        </p:nvSpPr>
+        <p:spPr>
+          <a:xfrm>
+            <a:off x="11434917" y="6222490"/>
+            <a:ext cx="491612" cy="400110"/>
+          </a:xfrm>
+          <a:prstGeom prst="rect">
+            <a:avLst/>
+          </a:prstGeom>
+          <a:noFill/>
+        </p:spPr>
+        <p:txBody>
+          <a:bodyPr wrap="square" rtlCol="0">
+            <a:spAutoFit/>
+          </a:bodyPr>
+          <a:lstStyle/>
+          <a:p>
+            <a:pPr algn="r"/>
+            <a:r>
+              <a:rPr lang="it-IT" sz="2000" b="1" dirty="0">
+                <a:solidFill>
+                  <a:schemeClr val="bg1"/>
+                </a:solidFill>
+              </a:rPr>
+              <a:t>60</a:t>
+            </a:r>
+          </a:p>
+        </p:txBody>
+      </p:sp>
+    </p:spTree>
+    <p:extLst>
+      <p:ext uri="{BB962C8B-B14F-4D97-AF65-F5344CB8AC3E}">
+        <p14:creationId xmlns:p14="http://schemas.microsoft.com/office/powerpoint/2010/main" val="2591765159"/>
+      </p:ext>
+    </p:extLst>
+  </p:cSld>
+  <p:clrMapOvr>
+    <a:masterClrMapping/>
+  </p:clrMapOvr>
+  <mc:AlternateContent xmlns:mc="http://schemas.openxmlformats.org/markup-compatibility/2006" xmlns:p159="http://schemas.microsoft.com/office/powerpoint/2015/09/main">
+    <mc:Choice Requires="p159">
+      <p:transition xmlns:p14="http://schemas.microsoft.com/office/powerpoint/2010/main" spd="slow" p14:dur="2000">
+        <p159:morph option="byObject"/>
+      </p:transition>
+    </mc:Choice>
+    <mc:Fallback xmlns="">
+      <p:transition spd="slow">
+        <p:fade/>
+      </p:transition>
+    </mc:Fallback>
+  </mc:AlternateContent>
+</p:sld>
+</file>
+
+<file path=ppt/slides/slide63.xml><?xml version="1.0" encoding="utf-8"?>
+<p:sld xmlns:a="http://schemas.openxmlformats.org/drawingml/2006/main" xmlns:r="http://schemas.openxmlformats.org/officeDocument/2006/relationships" xmlns:p="http://schemas.openxmlformats.org/presentationml/2006/main">
+  <p:cSld>
+    <p:spTree>
+      <p:nvGrpSpPr>
+        <p:cNvPr id="1" name="">
+          <a:extLst>
+            <a:ext uri="{FF2B5EF4-FFF2-40B4-BE49-F238E27FC236}">
+              <a16:creationId xmlns:a16="http://schemas.microsoft.com/office/drawing/2014/main" id="{BA88C47B-CCFF-01DA-5C5A-E248B1AB4AF8}"/>
+            </a:ext>
+          </a:extLst>
+        </p:cNvPr>
+        <p:cNvGrpSpPr/>
+        <p:nvPr/>
+      </p:nvGrpSpPr>
+      <p:grpSpPr>
+        <a:xfrm>
+          <a:off x="0" y="0"/>
+          <a:ext cx="0" cy="0"/>
+          <a:chOff x="0" y="0"/>
+          <a:chExt cx="0" cy="0"/>
+        </a:xfrm>
+      </p:grpSpPr>
+      <p:sp>
+        <p:nvSpPr>
+          <p:cNvPr id="5" name="Rettangolo 4">
+            <a:extLst>
+              <a:ext uri="{FF2B5EF4-FFF2-40B4-BE49-F238E27FC236}">
+                <a16:creationId xmlns:a16="http://schemas.microsoft.com/office/drawing/2014/main" id="{1E7219C2-AA34-CE2E-7A4A-463F259EEEE6}"/>
+              </a:ext>
+            </a:extLst>
+          </p:cNvPr>
+          <p:cNvSpPr/>
+          <p:nvPr/>
+        </p:nvSpPr>
+        <p:spPr>
+          <a:xfrm rot="16200000">
+            <a:off x="5612871" y="326546"/>
+            <a:ext cx="966258" cy="12192000"/>
+          </a:xfrm>
+          <a:prstGeom prst="rect">
+            <a:avLst/>
+          </a:prstGeom>
+          <a:solidFill>
+            <a:srgbClr val="990000"/>
+          </a:solidFill>
+          <a:ln>
+            <a:solidFill>
+              <a:srgbClr val="990000"/>
+            </a:solidFill>
+          </a:ln>
+        </p:spPr>
+        <p:style>
+          <a:lnRef idx="2">
+            <a:schemeClr val="accent1">
+              <a:shade val="15000"/>
+            </a:schemeClr>
+          </a:lnRef>
+          <a:fillRef idx="1">
+            <a:schemeClr val="accent1"/>
+          </a:fillRef>
+          <a:effectRef idx="0">
+            <a:schemeClr val="accent1"/>
+          </a:effectRef>
+          <a:fontRef idx="minor">
+            <a:schemeClr val="lt1"/>
+          </a:fontRef>
+        </p:style>
+        <p:txBody>
+          <a:bodyPr rtlCol="0" anchor="ctr"/>
+          <a:lstStyle/>
+          <a:p>
+            <a:pPr algn="ctr"/>
+            <a:endParaRPr lang="it-IT" dirty="0"/>
+          </a:p>
+        </p:txBody>
+      </p:sp>
+      <p:sp>
+        <p:nvSpPr>
+          <p:cNvPr id="6" name="CasellaDiTesto 5">
+            <a:extLst>
+              <a:ext uri="{FF2B5EF4-FFF2-40B4-BE49-F238E27FC236}">
+                <a16:creationId xmlns:a16="http://schemas.microsoft.com/office/drawing/2014/main" id="{D022BB71-A4BC-3330-247F-08F0656A9CFA}"/>
+              </a:ext>
+            </a:extLst>
+          </p:cNvPr>
+          <p:cNvSpPr txBox="1"/>
+          <p:nvPr/>
+        </p:nvSpPr>
+        <p:spPr>
+          <a:xfrm>
+            <a:off x="5086139" y="6222490"/>
+            <a:ext cx="2019720" cy="400110"/>
+          </a:xfrm>
+          <a:prstGeom prst="rect">
+            <a:avLst/>
+          </a:prstGeom>
+          <a:noFill/>
+        </p:spPr>
+        <p:txBody>
+          <a:bodyPr wrap="square" rtlCol="0">
+            <a:spAutoFit/>
+          </a:bodyPr>
+          <a:lstStyle/>
+          <a:p>
+            <a:pPr algn="r"/>
+            <a:r>
+              <a:rPr lang="it-IT" sz="2000" b="1" dirty="0">
+                <a:solidFill>
+                  <a:schemeClr val="bg1"/>
+                </a:solidFill>
+              </a:rPr>
+              <a:t>Gianpaolo Pestilli</a:t>
+            </a:r>
+          </a:p>
+        </p:txBody>
+      </p:sp>
+      <p:sp>
+        <p:nvSpPr>
+          <p:cNvPr id="8" name="CasellaDiTesto 7">
+            <a:extLst>
+              <a:ext uri="{FF2B5EF4-FFF2-40B4-BE49-F238E27FC236}">
+                <a16:creationId xmlns:a16="http://schemas.microsoft.com/office/drawing/2014/main" id="{B671853E-6C02-060C-F120-65BB96E60B4C}"/>
+              </a:ext>
+            </a:extLst>
+          </p:cNvPr>
+          <p:cNvSpPr txBox="1"/>
+          <p:nvPr/>
+        </p:nvSpPr>
+        <p:spPr>
+          <a:xfrm>
+            <a:off x="533399" y="728069"/>
+            <a:ext cx="11116884" cy="2416046"/>
+          </a:xfrm>
+          <a:prstGeom prst="rect">
+            <a:avLst/>
+          </a:prstGeom>
+          <a:noFill/>
+        </p:spPr>
+        <p:txBody>
+          <a:bodyPr wrap="square" rtlCol="0">
+            <a:spAutoFit/>
+          </a:bodyPr>
+          <a:lstStyle/>
+          <a:p>
+            <a:pPr algn="just">
+              <a:spcAft>
+                <a:spcPts val="600"/>
+              </a:spcAft>
+            </a:pPr>
+            <a:r>
+              <a:rPr lang="it-IT" sz="4000" b="1" dirty="0">
+                <a:solidFill>
+                  <a:srgbClr val="990000"/>
+                </a:solidFill>
+              </a:rPr>
+              <a:t>PERFORMANCE</a:t>
+            </a:r>
+          </a:p>
+          <a:p>
+            <a:pPr algn="just">
+              <a:spcAft>
+                <a:spcPts val="600"/>
+              </a:spcAft>
+            </a:pPr>
+            <a:r>
+              <a:rPr lang="it-IT" sz="3200" b="1" dirty="0"/>
+              <a:t>Algoritmi valutati in base a:</a:t>
+            </a:r>
+          </a:p>
+          <a:p>
+            <a:pPr marL="457200" indent="-457200" algn="just">
+              <a:spcAft>
+                <a:spcPts val="600"/>
+              </a:spcAft>
+              <a:buFont typeface="Arial" panose="020B0604020202020204" pitchFamily="34" charset="0"/>
+              <a:buChar char="•"/>
+            </a:pPr>
+            <a:r>
+              <a:rPr lang="it-IT" sz="3200" dirty="0"/>
+              <a:t>Rapporto di approssimazione medio</a:t>
+            </a:r>
+          </a:p>
+          <a:p>
+            <a:pPr marL="457200" indent="-457200" algn="just">
+              <a:spcAft>
+                <a:spcPts val="600"/>
+              </a:spcAft>
+              <a:buFont typeface="Arial" panose="020B0604020202020204" pitchFamily="34" charset="0"/>
+              <a:buChar char="•"/>
+            </a:pPr>
+            <a:r>
+              <a:rPr lang="it-IT" sz="3200" dirty="0"/>
+              <a:t>Tempo di esecuzione medio</a:t>
+            </a:r>
+          </a:p>
+        </p:txBody>
+      </p:sp>
+      <p:sp>
+        <p:nvSpPr>
+          <p:cNvPr id="2" name="CasellaDiTesto 1">
+            <a:extLst>
+              <a:ext uri="{FF2B5EF4-FFF2-40B4-BE49-F238E27FC236}">
+                <a16:creationId xmlns:a16="http://schemas.microsoft.com/office/drawing/2014/main" id="{63B6912E-24BE-0E8F-AB0E-6B086C8666FF}"/>
+              </a:ext>
+            </a:extLst>
+          </p:cNvPr>
+          <p:cNvSpPr txBox="1"/>
+          <p:nvPr/>
+        </p:nvSpPr>
+        <p:spPr>
+          <a:xfrm>
+            <a:off x="11434917" y="6222490"/>
+            <a:ext cx="491612" cy="400110"/>
+          </a:xfrm>
+          <a:prstGeom prst="rect">
+            <a:avLst/>
+          </a:prstGeom>
+          <a:noFill/>
+        </p:spPr>
+        <p:txBody>
+          <a:bodyPr wrap="square" rtlCol="0">
+            <a:spAutoFit/>
+          </a:bodyPr>
+          <a:lstStyle/>
+          <a:p>
+            <a:pPr algn="r"/>
+            <a:r>
+              <a:rPr lang="it-IT" sz="2000" b="1" dirty="0">
+                <a:solidFill>
+                  <a:schemeClr val="bg1"/>
+                </a:solidFill>
+              </a:rPr>
+              <a:t>61</a:t>
+            </a:r>
+          </a:p>
+        </p:txBody>
+      </p:sp>
+    </p:spTree>
+    <p:extLst>
+      <p:ext uri="{BB962C8B-B14F-4D97-AF65-F5344CB8AC3E}">
+        <p14:creationId xmlns:p14="http://schemas.microsoft.com/office/powerpoint/2010/main" val="3351515646"/>
       </p:ext>
     </p:extLst>
   </p:cSld>

</xml_diff>

<commit_message>
Upload progetto completo senza CSV
</commit_message>
<xml_diff>
--- a/Risultati_0386492.pptx
+++ b/Risultati_0386492.pptx
@@ -5,7 +5,7 @@
     <p:sldMasterId id="2147483648" r:id="rId1"/>
   </p:sldMasterIdLst>
   <p:notesMasterIdLst>
-    <p:notesMasterId r:id="rId65"/>
+    <p:notesMasterId r:id="rId66"/>
   </p:notesMasterIdLst>
   <p:sldIdLst>
     <p:sldId id="256" r:id="rId2"/>
@@ -70,7 +70,8 @@
     <p:sldId id="304" r:id="rId61"/>
     <p:sldId id="318" r:id="rId62"/>
     <p:sldId id="319" r:id="rId63"/>
-    <p:sldId id="320" r:id="rId64"/>
+    <p:sldId id="321" r:id="rId64"/>
+    <p:sldId id="320" r:id="rId65"/>
   </p:sldIdLst>
   <p:sldSz cx="12192000" cy="6858000"/>
   <p:notesSz cx="6858000" cy="9144000"/>
@@ -259,7 +260,7 @@
           <a:p>
             <a:fld id="{E0C88626-8297-4000-AA78-E4F17AAF9259}" type="datetimeFigureOut">
               <a:rPr lang="it-IT" smtClean="0"/>
-              <a:t>25/06/2026</a:t>
+              <a:t>27/06/2026</a:t>
             </a:fld>
             <a:endParaRPr lang="it-IT"/>
           </a:p>
@@ -673,7 +674,7 @@
           <a:p>
             <a:fld id="{4EEC3E97-3DDD-4186-A208-B850F35723DB}" type="datetime1">
               <a:rPr lang="it-IT" smtClean="0"/>
-              <a:t>25/06/2026</a:t>
+              <a:t>27/06/2026</a:t>
             </a:fld>
             <a:endParaRPr lang="it-IT"/>
           </a:p>
@@ -871,7 +872,7 @@
           <a:p>
             <a:fld id="{88C2FBA6-F7A9-4C74-B465-9FF20E4A7E98}" type="datetime1">
               <a:rPr lang="it-IT" smtClean="0"/>
-              <a:t>25/06/2026</a:t>
+              <a:t>27/06/2026</a:t>
             </a:fld>
             <a:endParaRPr lang="it-IT"/>
           </a:p>
@@ -1079,7 +1080,7 @@
           <a:p>
             <a:fld id="{7C289735-B0FA-42EC-B352-C4875869C0BC}" type="datetime1">
               <a:rPr lang="it-IT" smtClean="0"/>
-              <a:t>25/06/2026</a:t>
+              <a:t>27/06/2026</a:t>
             </a:fld>
             <a:endParaRPr lang="it-IT"/>
           </a:p>
@@ -1277,7 +1278,7 @@
           <a:p>
             <a:fld id="{10E9C9B6-BFF0-438D-B09E-8432B8734EE5}" type="datetime1">
               <a:rPr lang="it-IT" smtClean="0"/>
-              <a:t>25/06/2026</a:t>
+              <a:t>27/06/2026</a:t>
             </a:fld>
             <a:endParaRPr lang="it-IT"/>
           </a:p>
@@ -1552,7 +1553,7 @@
           <a:p>
             <a:fld id="{ABFC7979-BD5D-4D0F-9310-241562FF9E94}" type="datetime1">
               <a:rPr lang="it-IT" smtClean="0"/>
-              <a:t>25/06/2026</a:t>
+              <a:t>27/06/2026</a:t>
             </a:fld>
             <a:endParaRPr lang="it-IT"/>
           </a:p>
@@ -1817,7 +1818,7 @@
           <a:p>
             <a:fld id="{E6C8F376-66C7-47F4-9CDC-69997AFD8804}" type="datetime1">
               <a:rPr lang="it-IT" smtClean="0"/>
-              <a:t>25/06/2026</a:t>
+              <a:t>27/06/2026</a:t>
             </a:fld>
             <a:endParaRPr lang="it-IT"/>
           </a:p>
@@ -2229,7 +2230,7 @@
           <a:p>
             <a:fld id="{DD3CE95E-26FA-4B50-AEEC-A0C3476A6D97}" type="datetime1">
               <a:rPr lang="it-IT" smtClean="0"/>
-              <a:t>25/06/2026</a:t>
+              <a:t>27/06/2026</a:t>
             </a:fld>
             <a:endParaRPr lang="it-IT"/>
           </a:p>
@@ -2370,7 +2371,7 @@
           <a:p>
             <a:fld id="{6E6C9EBA-B4EE-4B7C-8D99-E4EE9B4515D3}" type="datetime1">
               <a:rPr lang="it-IT" smtClean="0"/>
-              <a:t>25/06/2026</a:t>
+              <a:t>27/06/2026</a:t>
             </a:fld>
             <a:endParaRPr lang="it-IT"/>
           </a:p>
@@ -2483,7 +2484,7 @@
           <a:p>
             <a:fld id="{DE74029C-F4FA-44C2-8417-402E4F9F070D}" type="datetime1">
               <a:rPr lang="it-IT" smtClean="0"/>
-              <a:t>25/06/2026</a:t>
+              <a:t>27/06/2026</a:t>
             </a:fld>
             <a:endParaRPr lang="it-IT"/>
           </a:p>
@@ -2794,7 +2795,7 @@
           <a:p>
             <a:fld id="{A99525BE-1E49-4B4B-B3DA-784C3A60B941}" type="datetime1">
               <a:rPr lang="it-IT" smtClean="0"/>
-              <a:t>25/06/2026</a:t>
+              <a:t>27/06/2026</a:t>
             </a:fld>
             <a:endParaRPr lang="it-IT"/>
           </a:p>
@@ -3082,7 +3083,7 @@
           <a:p>
             <a:fld id="{D2BC9992-29B7-4892-A984-BAD5A3D1DFD6}" type="datetime1">
               <a:rPr lang="it-IT" smtClean="0"/>
-              <a:t>25/06/2026</a:t>
+              <a:t>27/06/2026</a:t>
             </a:fld>
             <a:endParaRPr lang="it-IT"/>
           </a:p>
@@ -3323,7 +3324,7 @@
           <a:p>
             <a:fld id="{C55A07EC-953A-454F-8426-34AAF06A63B6}" type="datetime1">
               <a:rPr lang="it-IT" smtClean="0"/>
-              <a:t>25/06/2026</a:t>
+              <a:t>27/06/2026</a:t>
             </a:fld>
             <a:endParaRPr lang="it-IT"/>
           </a:p>
@@ -17127,12 +17128,17 @@
             </a:r>
             <a:r>
               <a:rPr lang="it-IT" sz="3200" dirty="0" err="1"/>
-              <a:t>handshaking</a:t>
+              <a:t>Handshaking</a:t>
             </a:r>
             <a:r>
               <a:rPr lang="it-IT" sz="3200" dirty="0"/>
-              <a:t> lemma si prende un vertice qualsiasi e, se non ha già grado massimo, si aumenta il suo grado di 1.</a:t>
-            </a:r>
+              <a:t> Lemma si prende un vertice qualsiasi e se ne modifica </a:t>
+            </a:r>
+            <a:r>
+              <a:rPr lang="it-IT" sz="3200"/>
+              <a:t>il grado di 1.</a:t>
+            </a:r>
+            <a:endParaRPr lang="it-IT" sz="3200" dirty="0"/>
           </a:p>
         </p:txBody>
       </p:sp>
@@ -21217,8 +21223,8 @@
           </a:p>
         </p:txBody>
       </p:sp>
-      <mc:AlternateContent xmlns:mc="http://schemas.openxmlformats.org/markup-compatibility/2006">
-        <mc:Choice xmlns:a14="http://schemas.microsoft.com/office/drawing/2010/main" Requires="a14">
+      <mc:AlternateContent xmlns:mc="http://schemas.openxmlformats.org/markup-compatibility/2006" xmlns:a14="http://schemas.microsoft.com/office/drawing/2010/main">
+        <mc:Choice Requires="a14">
           <p:sp>
             <p:nvSpPr>
               <p:cNvPr id="8" name="CasellaDiTesto 7">
@@ -21332,7 +21338,7 @@
             </p:txBody>
           </p:sp>
         </mc:Choice>
-        <mc:Fallback>
+        <mc:Fallback xmlns="">
           <p:sp>
             <p:nvSpPr>
               <p:cNvPr id="8" name="CasellaDiTesto 7">
@@ -22534,7 +22540,7 @@
         <p:spPr>
           <a:xfrm>
             <a:off x="533399" y="728069"/>
-            <a:ext cx="11116884" cy="4955203"/>
+            <a:ext cx="11116884" cy="4385816"/>
           </a:xfrm>
           <a:prstGeom prst="rect">
             <a:avLst/>
@@ -22617,30 +22623,6 @@
               <a:rPr lang="it-IT" sz="3200" dirty="0"/>
               <a:t> con licenza accademica (ritenuto il migliore per problemi relativi ai grafi).</a:t>
             </a:r>
-          </a:p>
-          <a:p>
-            <a:pPr algn="just">
-              <a:spcAft>
-                <a:spcPts val="600"/>
-              </a:spcAft>
-            </a:pPr>
-            <a:r>
-              <a:rPr lang="it-IT" sz="3200" b="1" dirty="0"/>
-              <a:t>Tempo di </a:t>
-            </a:r>
-            <a:r>
-              <a:rPr lang="it-IT" sz="3200" b="1" dirty="0" err="1"/>
-              <a:t>timeout</a:t>
-            </a:r>
-            <a:r>
-              <a:rPr lang="it-IT" sz="3200" b="1" dirty="0"/>
-              <a:t>: </a:t>
-            </a:r>
-            <a:r>
-              <a:rPr lang="it-IT" sz="3200" dirty="0"/>
-              <a:t>300 secondi.</a:t>
-            </a:r>
-            <a:endParaRPr lang="it-IT" sz="3200" b="1" dirty="0"/>
           </a:p>
         </p:txBody>
       </p:sp>
@@ -22841,7 +22823,7 @@
         <p:spPr>
           <a:xfrm>
             <a:off x="533399" y="728069"/>
-            <a:ext cx="11116884" cy="4385816"/>
+            <a:ext cx="11116884" cy="4878259"/>
           </a:xfrm>
           <a:prstGeom prst="rect">
             <a:avLst/>
@@ -22889,6 +22871,22 @@
                 <a:spcPts val="600"/>
               </a:spcAft>
             </a:pPr>
+            <a:r>
+              <a:rPr lang="it-IT" sz="3200" b="1" dirty="0"/>
+              <a:t>Tempo di </a:t>
+            </a:r>
+            <a:r>
+              <a:rPr lang="it-IT" sz="3200" b="1" dirty="0" err="1"/>
+              <a:t>timeout</a:t>
+            </a:r>
+            <a:r>
+              <a:rPr lang="it-IT" sz="3200" b="1" dirty="0"/>
+              <a:t>: </a:t>
+            </a:r>
+            <a:r>
+              <a:rPr lang="it-IT" sz="3200" dirty="0"/>
+              <a:t>300 secondi, sia per l’algoritmo che utilizza il rilassamento lineare, sia per il calcolo della soluzione ottima.</a:t>
+            </a:r>
             <a:endParaRPr lang="it-IT" sz="3200" b="1" dirty="0"/>
           </a:p>
           <a:p>
@@ -23014,7 +23012,7 @@
         <p:cNvPr id="1" name="">
           <a:extLst>
             <a:ext uri="{FF2B5EF4-FFF2-40B4-BE49-F238E27FC236}">
-              <a16:creationId xmlns:a16="http://schemas.microsoft.com/office/drawing/2014/main" id="{BA88C47B-CCFF-01DA-5C5A-E248B1AB4AF8}"/>
+              <a16:creationId xmlns:a16="http://schemas.microsoft.com/office/drawing/2014/main" id="{8E8184BD-10B8-CC69-B8C5-E971F13D1A99}"/>
             </a:ext>
           </a:extLst>
         </p:cNvPr>
@@ -23034,7 +23032,7 @@
           <p:cNvPr id="5" name="Rettangolo 4">
             <a:extLst>
               <a:ext uri="{FF2B5EF4-FFF2-40B4-BE49-F238E27FC236}">
-                <a16:creationId xmlns:a16="http://schemas.microsoft.com/office/drawing/2014/main" id="{1E7219C2-AA34-CE2E-7A4A-463F259EEEE6}"/>
+                <a16:creationId xmlns:a16="http://schemas.microsoft.com/office/drawing/2014/main" id="{4510E97F-1506-132C-BD5D-A8BC8AFA8A03}"/>
               </a:ext>
             </a:extLst>
           </p:cNvPr>
@@ -23088,6 +23086,299 @@
           <p:cNvPr id="6" name="CasellaDiTesto 5">
             <a:extLst>
               <a:ext uri="{FF2B5EF4-FFF2-40B4-BE49-F238E27FC236}">
+                <a16:creationId xmlns:a16="http://schemas.microsoft.com/office/drawing/2014/main" id="{FC7D1CBE-94E2-289D-4D0D-F3B4BFF7FC3B}"/>
+              </a:ext>
+            </a:extLst>
+          </p:cNvPr>
+          <p:cNvSpPr txBox="1"/>
+          <p:nvPr/>
+        </p:nvSpPr>
+        <p:spPr>
+          <a:xfrm>
+            <a:off x="5086139" y="6222490"/>
+            <a:ext cx="2019720" cy="400110"/>
+          </a:xfrm>
+          <a:prstGeom prst="rect">
+            <a:avLst/>
+          </a:prstGeom>
+          <a:noFill/>
+        </p:spPr>
+        <p:txBody>
+          <a:bodyPr wrap="square" rtlCol="0">
+            <a:spAutoFit/>
+          </a:bodyPr>
+          <a:lstStyle/>
+          <a:p>
+            <a:pPr algn="r"/>
+            <a:r>
+              <a:rPr lang="it-IT" sz="2000" b="1" dirty="0">
+                <a:solidFill>
+                  <a:schemeClr val="bg1"/>
+                </a:solidFill>
+              </a:rPr>
+              <a:t>Gianpaolo Pestilli</a:t>
+            </a:r>
+          </a:p>
+        </p:txBody>
+      </p:sp>
+      <p:sp>
+        <p:nvSpPr>
+          <p:cNvPr id="8" name="CasellaDiTesto 7">
+            <a:extLst>
+              <a:ext uri="{FF2B5EF4-FFF2-40B4-BE49-F238E27FC236}">
+                <a16:creationId xmlns:a16="http://schemas.microsoft.com/office/drawing/2014/main" id="{6260B967-6C8B-5C2A-DEE9-91DFF8F492A5}"/>
+              </a:ext>
+            </a:extLst>
+          </p:cNvPr>
+          <p:cNvSpPr txBox="1"/>
+          <p:nvPr/>
+        </p:nvSpPr>
+        <p:spPr>
+          <a:xfrm>
+            <a:off x="533399" y="728069"/>
+            <a:ext cx="11116884" cy="4308872"/>
+          </a:xfrm>
+          <a:prstGeom prst="rect">
+            <a:avLst/>
+          </a:prstGeom>
+          <a:noFill/>
+        </p:spPr>
+        <p:txBody>
+          <a:bodyPr wrap="square" rtlCol="0">
+            <a:spAutoFit/>
+          </a:bodyPr>
+          <a:lstStyle/>
+          <a:p>
+            <a:pPr algn="just">
+              <a:spcAft>
+                <a:spcPts val="600"/>
+              </a:spcAft>
+            </a:pPr>
+            <a:r>
+              <a:rPr lang="it-IT" sz="4000" b="1" dirty="0">
+                <a:solidFill>
+                  <a:srgbClr val="990000"/>
+                </a:solidFill>
+              </a:rPr>
+              <a:t>ASSUNZIONI</a:t>
+            </a:r>
+          </a:p>
+          <a:p>
+            <a:pPr algn="just">
+              <a:spcAft>
+                <a:spcPts val="600"/>
+              </a:spcAft>
+            </a:pPr>
+            <a:r>
+              <a:rPr lang="it-IT" sz="3200" b="1" dirty="0"/>
+              <a:t>Crash del solver nel calcolo dell’ottimo: </a:t>
+            </a:r>
+            <a:r>
+              <a:rPr lang="it-IT" sz="3200" dirty="0"/>
+              <a:t>se </a:t>
+            </a:r>
+            <a:r>
+              <a:rPr lang="it-IT" sz="3200" dirty="0" err="1"/>
+              <a:t>Gurobi</a:t>
+            </a:r>
+            <a:r>
+              <a:rPr lang="it-IT" sz="3200" dirty="0"/>
+              <a:t> riporta errori su una specifica istanza, quella viene ignorata poiché non si ha a disposizione alcun </a:t>
+            </a:r>
+            <a:r>
+              <a:rPr lang="it-IT" sz="3200" dirty="0" err="1"/>
+              <a:t>lower</a:t>
+            </a:r>
+            <a:r>
+              <a:rPr lang="it-IT" sz="3200" dirty="0"/>
+              <a:t> </a:t>
+            </a:r>
+            <a:r>
+              <a:rPr lang="it-IT" sz="3200" dirty="0" err="1"/>
+              <a:t>bound</a:t>
+            </a:r>
+            <a:r>
+              <a:rPr lang="it-IT" sz="3200" dirty="0"/>
+              <a:t> con cui fare confronti.</a:t>
+            </a:r>
+          </a:p>
+          <a:p>
+            <a:pPr algn="just">
+              <a:spcAft>
+                <a:spcPts val="600"/>
+              </a:spcAft>
+            </a:pPr>
+            <a:r>
+              <a:rPr lang="it-IT" sz="3200" b="1" dirty="0"/>
+              <a:t>Crash del solver nel calcolo dell’ottimo del rilassamento: </a:t>
+            </a:r>
+            <a:r>
+              <a:rPr lang="it-IT" sz="3200" dirty="0"/>
+              <a:t>se </a:t>
+            </a:r>
+            <a:r>
+              <a:rPr lang="it-IT" sz="3200" dirty="0" err="1"/>
+              <a:t>Gurobi</a:t>
+            </a:r>
+            <a:r>
+              <a:rPr lang="it-IT" sz="3200" dirty="0"/>
+              <a:t> non riesce a trovare alcun risultato entro 300 secondi e/o sorgono problemi di memoria, viene considerato come cover l’insieme di tutti i vertici </a:t>
+            </a:r>
+            <a:r>
+              <a:rPr lang="it-IT" sz="3200"/>
+              <a:t>del grafo.</a:t>
+            </a:r>
+            <a:endParaRPr lang="it-IT" sz="3200" b="1" dirty="0"/>
+          </a:p>
+        </p:txBody>
+      </p:sp>
+      <p:sp>
+        <p:nvSpPr>
+          <p:cNvPr id="2" name="CasellaDiTesto 1">
+            <a:extLst>
+              <a:ext uri="{FF2B5EF4-FFF2-40B4-BE49-F238E27FC236}">
+                <a16:creationId xmlns:a16="http://schemas.microsoft.com/office/drawing/2014/main" id="{047F045E-E3BE-105B-C090-80A0859C6FDF}"/>
+              </a:ext>
+            </a:extLst>
+          </p:cNvPr>
+          <p:cNvSpPr txBox="1"/>
+          <p:nvPr/>
+        </p:nvSpPr>
+        <p:spPr>
+          <a:xfrm>
+            <a:off x="11434917" y="6222490"/>
+            <a:ext cx="491612" cy="400110"/>
+          </a:xfrm>
+          <a:prstGeom prst="rect">
+            <a:avLst/>
+          </a:prstGeom>
+          <a:noFill/>
+        </p:spPr>
+        <p:txBody>
+          <a:bodyPr wrap="square" rtlCol="0">
+            <a:spAutoFit/>
+          </a:bodyPr>
+          <a:lstStyle/>
+          <a:p>
+            <a:pPr algn="r"/>
+            <a:r>
+              <a:rPr lang="it-IT" sz="2000" b="1" dirty="0">
+                <a:solidFill>
+                  <a:schemeClr val="bg1"/>
+                </a:solidFill>
+              </a:rPr>
+              <a:t>61</a:t>
+            </a:r>
+          </a:p>
+        </p:txBody>
+      </p:sp>
+    </p:spTree>
+    <p:extLst>
+      <p:ext uri="{BB962C8B-B14F-4D97-AF65-F5344CB8AC3E}">
+        <p14:creationId xmlns:p14="http://schemas.microsoft.com/office/powerpoint/2010/main" val="1103860728"/>
+      </p:ext>
+    </p:extLst>
+  </p:cSld>
+  <p:clrMapOvr>
+    <a:masterClrMapping/>
+  </p:clrMapOvr>
+  <mc:AlternateContent xmlns:mc="http://schemas.openxmlformats.org/markup-compatibility/2006" xmlns:p159="http://schemas.microsoft.com/office/powerpoint/2015/09/main">
+    <mc:Choice Requires="p159">
+      <p:transition xmlns:p14="http://schemas.microsoft.com/office/powerpoint/2010/main" spd="slow" p14:dur="2000">
+        <p159:morph option="byObject"/>
+      </p:transition>
+    </mc:Choice>
+    <mc:Fallback xmlns="">
+      <p:transition spd="slow">
+        <p:fade/>
+      </p:transition>
+    </mc:Fallback>
+  </mc:AlternateContent>
+</p:sld>
+</file>
+
+<file path=ppt/slides/slide64.xml><?xml version="1.0" encoding="utf-8"?>
+<p:sld xmlns:a="http://schemas.openxmlformats.org/drawingml/2006/main" xmlns:r="http://schemas.openxmlformats.org/officeDocument/2006/relationships" xmlns:p="http://schemas.openxmlformats.org/presentationml/2006/main">
+  <p:cSld>
+    <p:spTree>
+      <p:nvGrpSpPr>
+        <p:cNvPr id="1" name="">
+          <a:extLst>
+            <a:ext uri="{FF2B5EF4-FFF2-40B4-BE49-F238E27FC236}">
+              <a16:creationId xmlns:a16="http://schemas.microsoft.com/office/drawing/2014/main" id="{BA88C47B-CCFF-01DA-5C5A-E248B1AB4AF8}"/>
+            </a:ext>
+          </a:extLst>
+        </p:cNvPr>
+        <p:cNvGrpSpPr/>
+        <p:nvPr/>
+      </p:nvGrpSpPr>
+      <p:grpSpPr>
+        <a:xfrm>
+          <a:off x="0" y="0"/>
+          <a:ext cx="0" cy="0"/>
+          <a:chOff x="0" y="0"/>
+          <a:chExt cx="0" cy="0"/>
+        </a:xfrm>
+      </p:grpSpPr>
+      <p:sp>
+        <p:nvSpPr>
+          <p:cNvPr id="5" name="Rettangolo 4">
+            <a:extLst>
+              <a:ext uri="{FF2B5EF4-FFF2-40B4-BE49-F238E27FC236}">
+                <a16:creationId xmlns:a16="http://schemas.microsoft.com/office/drawing/2014/main" id="{1E7219C2-AA34-CE2E-7A4A-463F259EEEE6}"/>
+              </a:ext>
+            </a:extLst>
+          </p:cNvPr>
+          <p:cNvSpPr/>
+          <p:nvPr/>
+        </p:nvSpPr>
+        <p:spPr>
+          <a:xfrm rot="16200000">
+            <a:off x="5612871" y="326546"/>
+            <a:ext cx="966258" cy="12192000"/>
+          </a:xfrm>
+          <a:prstGeom prst="rect">
+            <a:avLst/>
+          </a:prstGeom>
+          <a:solidFill>
+            <a:srgbClr val="990000"/>
+          </a:solidFill>
+          <a:ln>
+            <a:solidFill>
+              <a:srgbClr val="990000"/>
+            </a:solidFill>
+          </a:ln>
+        </p:spPr>
+        <p:style>
+          <a:lnRef idx="2">
+            <a:schemeClr val="accent1">
+              <a:shade val="15000"/>
+            </a:schemeClr>
+          </a:lnRef>
+          <a:fillRef idx="1">
+            <a:schemeClr val="accent1"/>
+          </a:fillRef>
+          <a:effectRef idx="0">
+            <a:schemeClr val="accent1"/>
+          </a:effectRef>
+          <a:fontRef idx="minor">
+            <a:schemeClr val="lt1"/>
+          </a:fontRef>
+        </p:style>
+        <p:txBody>
+          <a:bodyPr rtlCol="0" anchor="ctr"/>
+          <a:lstStyle/>
+          <a:p>
+            <a:pPr algn="ctr"/>
+            <a:endParaRPr lang="it-IT" dirty="0"/>
+          </a:p>
+        </p:txBody>
+      </p:sp>
+      <p:sp>
+        <p:nvSpPr>
+          <p:cNvPr id="6" name="CasellaDiTesto 5">
+            <a:extLst>
+              <a:ext uri="{FF2B5EF4-FFF2-40B4-BE49-F238E27FC236}">
                 <a16:creationId xmlns:a16="http://schemas.microsoft.com/office/drawing/2014/main" id="{D022BB71-A4BC-3330-247F-08F0656A9CFA}"/>
               </a:ext>
             </a:extLst>
@@ -23239,7 +23530,7 @@
                   <a:schemeClr val="bg1"/>
                 </a:solidFill>
               </a:rPr>
-              <a:t>61</a:t>
+              <a:t>62</a:t>
             </a:r>
           </a:p>
         </p:txBody>

</xml_diff>